<commit_message>
폰트를 Pretendard(본문) · NEXON Lv1 Gothic(제목)으로 전면 교체
- HTML: 폰트 CDN이 CSP로 차단되므로 두 서체를 npm 패키지로 받아
  본문에 실제로 쓰인 496자만 서브셋(fontTools) 후 woff2 data URI로 내장.
  8종(Pretendard 400~900, NEXON 400/700) 합계 309 KB, 페이지 0.46 MB
- 역할 분리: 제목·헤드라인·KPI 수치는 NEXON Lv1 Gothic, 본문·라벨·표는 Pretendard
- 기존 monospace 라벨 역할도 Pretendard로 통합하고 tabular-nums 유지
- PPTX: 전 슬라이드 서체를 동일 규칙으로 교체 (Malgun Gothic 잔존 0)
- PPTX QA 렌더러를 실제 서체 메트릭 기반으로 교체해 레이아웃 재검증

Co-Authored-By: Claude Opus 5 <noreply@anthropic.com>
Claude-Session: https://claude.ai/code/session_0169v3x3R6DJLzqs84GmtLxG
</commit_message>
<xml_diff>
--- a/reports/Aurora_Amazon_Plush_Ranking_Analysis.pptx
+++ b/reports/Aurora_Amazon_Plush_Ranking_Analysis.pptx
@@ -159,7 +159,7 @@
                     <a:solidFill>
                       <a:srgbClr val="1F2937"/>
                     </a:solidFill>
-                    <a:latin typeface="Malgun Gothic"/>
+                    <a:latin typeface="Pretendard"/>
                   </a:defRPr>
                 </a:pPr>
               </a:p>
@@ -254,7 +254,7 @@
                   <a:solidFill>
                     <a:srgbClr val="1F2937"/>
                   </a:solidFill>
-                  <a:latin typeface="Malgun Gothic"/>
+                  <a:latin typeface="Pretendard"/>
                 </a:defRPr>
               </a:pPr>
             </a:p>
@@ -302,7 +302,7 @@
                 <a:solidFill>
                   <a:srgbClr val="1F2937"/>
                 </a:solidFill>
-                <a:latin typeface="Malgun Gothic"/>
+                <a:latin typeface="Pretendard"/>
               </a:defRPr>
             </a:pPr>
             <a:endParaRPr lang="en-US"/>
@@ -1879,9 +1879,9 @@
                 <a:solidFill>
                   <a:srgbClr val="1E3A8A"/>
                 </a:solidFill>
-                <a:latin typeface="Malgun Gothic" pitchFamily="34" charset="0"/>
-                <a:ea typeface="Malgun Gothic" pitchFamily="34" charset="-122"/>
-                <a:cs typeface="Malgun Gothic" pitchFamily="34" charset="-120"/>
+                <a:latin typeface="Pretendard" pitchFamily="34" charset="0"/>
+                <a:ea typeface="Pretendard" pitchFamily="34" charset="-122"/>
+                <a:cs typeface="Pretendard" pitchFamily="34" charset="-120"/>
               </a:rPr>
               <a:t>AURORA  |  PRODUCT PLANNING</a:t>
             </a:r>
@@ -1921,9 +1921,9 @@
                 <a:solidFill>
                   <a:srgbClr val="DC2626"/>
                 </a:solidFill>
-                <a:latin typeface="Malgun Gothic" pitchFamily="34" charset="0"/>
-                <a:ea typeface="Malgun Gothic" pitchFamily="34" charset="-122"/>
-                <a:cs typeface="Malgun Gothic" pitchFamily="34" charset="-120"/>
+                <a:latin typeface="NEXON Lv1 Gothic" pitchFamily="34" charset="0"/>
+                <a:ea typeface="NEXON Lv1 Gothic" pitchFamily="34" charset="-122"/>
+                <a:cs typeface="NEXON Lv1 Gothic" pitchFamily="34" charset="-120"/>
               </a:rPr>
               <a:t>Amazon 봉제완구 랭킹</a:t>
             </a:r>
@@ -1941,9 +1941,9 @@
                 <a:solidFill>
                   <a:srgbClr val="DC2626"/>
                 </a:solidFill>
-                <a:latin typeface="Malgun Gothic" pitchFamily="34" charset="0"/>
-                <a:ea typeface="Malgun Gothic" pitchFamily="34" charset="-122"/>
-                <a:cs typeface="Malgun Gothic" pitchFamily="34" charset="-120"/>
+                <a:latin typeface="NEXON Lv1 Gothic" pitchFamily="34" charset="0"/>
+                <a:ea typeface="NEXON Lv1 Gothic" pitchFamily="34" charset="-122"/>
+                <a:cs typeface="NEXON Lv1 Gothic" pitchFamily="34" charset="-120"/>
               </a:rPr>
               <a:t>4대 지표 교차분석</a:t>
             </a:r>
@@ -1980,9 +1980,9 @@
                 <a:solidFill>
                   <a:srgbClr val="1F2937"/>
                 </a:solidFill>
-                <a:latin typeface="Malgun Gothic" pitchFamily="34" charset="0"/>
-                <a:ea typeface="Malgun Gothic" pitchFamily="34" charset="-122"/>
-                <a:cs typeface="Malgun Gothic" pitchFamily="34" charset="-120"/>
+                <a:latin typeface="Pretendard" pitchFamily="34" charset="0"/>
+                <a:ea typeface="Pretendard" pitchFamily="34" charset="-122"/>
+                <a:cs typeface="Pretendard" pitchFamily="34" charset="-120"/>
               </a:rPr>
               <a:t>지금 팔리는 상품이 아니라, 앞으로 팔릴 상품을 찾는 프레임</a:t>
             </a:r>
@@ -2046,9 +2046,9 @@
                 <a:solidFill>
                   <a:srgbClr val="DC2626"/>
                 </a:solidFill>
-                <a:latin typeface="Malgun Gothic" pitchFamily="34" charset="0"/>
-                <a:ea typeface="Malgun Gothic" pitchFamily="34" charset="-122"/>
-                <a:cs typeface="Malgun Gothic" pitchFamily="34" charset="-120"/>
+                <a:latin typeface="Pretendard" pitchFamily="34" charset="0"/>
+                <a:ea typeface="Pretendard" pitchFamily="34" charset="-122"/>
+                <a:cs typeface="Pretendard" pitchFamily="34" charset="-120"/>
               </a:rPr>
               <a:t>BEST SELLERS</a:t>
             </a:r>
@@ -2112,9 +2112,9 @@
                 <a:solidFill>
                   <a:srgbClr val="1E3A8A"/>
                 </a:solidFill>
-                <a:latin typeface="Malgun Gothic" pitchFamily="34" charset="0"/>
-                <a:ea typeface="Malgun Gothic" pitchFamily="34" charset="-122"/>
-                <a:cs typeface="Malgun Gothic" pitchFamily="34" charset="-120"/>
+                <a:latin typeface="Pretendard" pitchFamily="34" charset="0"/>
+                <a:ea typeface="Pretendard" pitchFamily="34" charset="-122"/>
+                <a:cs typeface="Pretendard" pitchFamily="34" charset="-120"/>
               </a:rPr>
               <a:t>MOVERS &amp; SHAKERS</a:t>
             </a:r>
@@ -2178,9 +2178,9 @@
                 <a:solidFill>
                   <a:srgbClr val="1E3A8A"/>
                 </a:solidFill>
-                <a:latin typeface="Malgun Gothic" pitchFamily="34" charset="0"/>
-                <a:ea typeface="Malgun Gothic" pitchFamily="34" charset="-122"/>
-                <a:cs typeface="Malgun Gothic" pitchFamily="34" charset="-120"/>
+                <a:latin typeface="Pretendard" pitchFamily="34" charset="0"/>
+                <a:ea typeface="Pretendard" pitchFamily="34" charset="-122"/>
+                <a:cs typeface="Pretendard" pitchFamily="34" charset="-120"/>
               </a:rPr>
               <a:t>NEW RELEASES</a:t>
             </a:r>
@@ -2244,9 +2244,9 @@
                 <a:solidFill>
                   <a:srgbClr val="1E3A8A"/>
                 </a:solidFill>
-                <a:latin typeface="Malgun Gothic" pitchFamily="34" charset="0"/>
-                <a:ea typeface="Malgun Gothic" pitchFamily="34" charset="-122"/>
-                <a:cs typeface="Malgun Gothic" pitchFamily="34" charset="-120"/>
+                <a:latin typeface="Pretendard" pitchFamily="34" charset="0"/>
+                <a:ea typeface="Pretendard" pitchFamily="34" charset="-122"/>
+                <a:cs typeface="Pretendard" pitchFamily="34" charset="-120"/>
               </a:rPr>
               <a:t>MOST WISHED FOR</a:t>
             </a:r>
@@ -2283,9 +2283,9 @@
                 <a:solidFill>
                   <a:srgbClr val="1F2937"/>
                 </a:solidFill>
-                <a:latin typeface="Malgun Gothic" pitchFamily="34" charset="0"/>
-                <a:ea typeface="Malgun Gothic" pitchFamily="34" charset="-122"/>
-                <a:cs typeface="Malgun Gothic" pitchFamily="34" charset="-120"/>
+                <a:latin typeface="Pretendard" pitchFamily="34" charset="0"/>
+                <a:ea typeface="Pretendard" pitchFamily="34" charset="-122"/>
+                <a:cs typeface="Pretendard" pitchFamily="34" charset="-120"/>
               </a:rPr>
               <a:t>미국 Amazon  &gt;  Toys &amp; Games  &gt;  Stuffed Animals &amp; Plush Toys</a:t>
             </a:r>
@@ -2322,9 +2322,9 @@
                 <a:solidFill>
                   <a:srgbClr val="6B7280"/>
                 </a:solidFill>
-                <a:latin typeface="Malgun Gothic" pitchFamily="34" charset="0"/>
-                <a:ea typeface="Malgun Gothic" pitchFamily="34" charset="-122"/>
-                <a:cs typeface="Malgun Gothic" pitchFamily="34" charset="-120"/>
+                <a:latin typeface="Pretendard" pitchFamily="34" charset="0"/>
+                <a:ea typeface="Pretendard" pitchFamily="34" charset="-122"/>
+                <a:cs typeface="Pretendard" pitchFamily="34" charset="-120"/>
               </a:rPr>
               <a:t>작성 : 상품기획팀   |   데이터 기준일 : 2026. 08. 11. (금일 조회 기준)   |   랭킹은 시간·지역에 따라 변동</a:t>
             </a:r>
@@ -2393,9 +2393,9 @@
                 <a:solidFill>
                   <a:srgbClr val="1E3A8A"/>
                 </a:solidFill>
-                <a:latin typeface="Malgun Gothic" pitchFamily="34" charset="0"/>
-                <a:ea typeface="Malgun Gothic" pitchFamily="34" charset="-122"/>
-                <a:cs typeface="Malgun Gothic" pitchFamily="34" charset="-120"/>
+                <a:latin typeface="Pretendard" pitchFamily="34" charset="0"/>
+                <a:ea typeface="Pretendard" pitchFamily="34" charset="-122"/>
+                <a:cs typeface="Pretendard" pitchFamily="34" charset="-120"/>
               </a:rPr>
               <a:t>EXECUTIVE SUMMARY</a:t>
             </a:r>
@@ -2432,9 +2432,9 @@
                 <a:solidFill>
                   <a:srgbClr val="DC2626"/>
                 </a:solidFill>
-                <a:latin typeface="Malgun Gothic" pitchFamily="34" charset="0"/>
-                <a:ea typeface="Malgun Gothic" pitchFamily="34" charset="-122"/>
-                <a:cs typeface="Malgun Gothic" pitchFamily="34" charset="-120"/>
+                <a:latin typeface="NEXON Lv1 Gothic" pitchFamily="34" charset="0"/>
+                <a:ea typeface="NEXON Lv1 Gothic" pitchFamily="34" charset="-122"/>
+                <a:cs typeface="NEXON Lv1 Gothic" pitchFamily="34" charset="-120"/>
               </a:rPr>
               <a:t>핵심 요약</a:t>
             </a:r>
@@ -2523,9 +2523,9 @@
                 <a:solidFill>
                   <a:srgbClr val="FFFFFF"/>
                 </a:solidFill>
-                <a:latin typeface="Malgun Gothic" pitchFamily="34" charset="0"/>
-                <a:ea typeface="Malgun Gothic" pitchFamily="34" charset="-122"/>
-                <a:cs typeface="Malgun Gothic" pitchFamily="34" charset="-120"/>
+                <a:latin typeface="Pretendard" pitchFamily="34" charset="0"/>
+                <a:ea typeface="Pretendard" pitchFamily="34" charset="-122"/>
+                <a:cs typeface="Pretendard" pitchFamily="34" charset="-120"/>
               </a:rPr>
               <a:t>1</a:t>
             </a:r>
@@ -2562,9 +2562,9 @@
                 <a:solidFill>
                   <a:srgbClr val="1E3A8A"/>
                 </a:solidFill>
-                <a:latin typeface="Malgun Gothic" pitchFamily="34" charset="0"/>
-                <a:ea typeface="Malgun Gothic" pitchFamily="34" charset="-122"/>
-                <a:cs typeface="Malgun Gothic" pitchFamily="34" charset="-120"/>
+                <a:latin typeface="Pretendard" pitchFamily="34" charset="0"/>
+                <a:ea typeface="Pretendard" pitchFamily="34" charset="-122"/>
+                <a:cs typeface="Pretendard" pitchFamily="34" charset="-120"/>
               </a:rPr>
               <a:t>4개 랭킹은 서로 다른 시점을 본다</a:t>
             </a:r>
@@ -2601,9 +2601,9 @@
                 <a:solidFill>
                   <a:srgbClr val="1F2937"/>
                 </a:solidFill>
-                <a:latin typeface="Malgun Gothic" pitchFamily="34" charset="0"/>
-                <a:ea typeface="Malgun Gothic" pitchFamily="34" charset="-122"/>
-                <a:cs typeface="Malgun Gothic" pitchFamily="34" charset="-120"/>
+                <a:latin typeface="Pretendard" pitchFamily="34" charset="0"/>
+                <a:ea typeface="Pretendard" pitchFamily="34" charset="-122"/>
+                <a:cs typeface="Pretendard" pitchFamily="34" charset="-120"/>
               </a:rPr>
               <a:t>현재 매출 · 24시간 급등 · 신상품 반응 · 미래 구매의향</a:t>
             </a:r>
@@ -2692,9 +2692,9 @@
                 <a:solidFill>
                   <a:srgbClr val="FFFFFF"/>
                 </a:solidFill>
-                <a:latin typeface="Malgun Gothic" pitchFamily="34" charset="0"/>
-                <a:ea typeface="Malgun Gothic" pitchFamily="34" charset="-122"/>
-                <a:cs typeface="Malgun Gothic" pitchFamily="34" charset="-120"/>
+                <a:latin typeface="Pretendard" pitchFamily="34" charset="0"/>
+                <a:ea typeface="Pretendard" pitchFamily="34" charset="-122"/>
+                <a:cs typeface="Pretendard" pitchFamily="34" charset="-120"/>
               </a:rPr>
               <a:t>2</a:t>
             </a:r>
@@ -2731,9 +2731,9 @@
                 <a:solidFill>
                   <a:srgbClr val="1E3A8A"/>
                 </a:solidFill>
-                <a:latin typeface="Malgun Gothic" pitchFamily="34" charset="0"/>
-                <a:ea typeface="Malgun Gothic" pitchFamily="34" charset="-122"/>
-                <a:cs typeface="Malgun Gothic" pitchFamily="34" charset="-120"/>
+                <a:latin typeface="Pretendard" pitchFamily="34" charset="0"/>
+                <a:ea typeface="Pretendard" pitchFamily="34" charset="-122"/>
+                <a:cs typeface="Pretendard" pitchFamily="34" charset="-120"/>
               </a:rPr>
               <a:t>교차 지점에서 성장 상품군이 드러난다</a:t>
             </a:r>
@@ -2770,9 +2770,9 @@
                 <a:solidFill>
                   <a:srgbClr val="1F2937"/>
                 </a:solidFill>
-                <a:latin typeface="Malgun Gothic" pitchFamily="34" charset="0"/>
-                <a:ea typeface="Malgun Gothic" pitchFamily="34" charset="-122"/>
-                <a:cs typeface="Malgun Gothic" pitchFamily="34" charset="-120"/>
+                <a:latin typeface="Pretendard" pitchFamily="34" charset="0"/>
+                <a:ea typeface="Pretendard" pitchFamily="34" charset="-122"/>
+                <a:cs typeface="Pretendard" pitchFamily="34" charset="-120"/>
               </a:rPr>
               <a:t>미니 플러시·백참, 블라인드박스, 기능성 힐링 plush</a:t>
             </a:r>
@@ -2861,9 +2861,9 @@
                 <a:solidFill>
                   <a:srgbClr val="FFFFFF"/>
                 </a:solidFill>
-                <a:latin typeface="Malgun Gothic" pitchFamily="34" charset="0"/>
-                <a:ea typeface="Malgun Gothic" pitchFamily="34" charset="-122"/>
-                <a:cs typeface="Malgun Gothic" pitchFamily="34" charset="-120"/>
+                <a:latin typeface="Pretendard" pitchFamily="34" charset="0"/>
+                <a:ea typeface="Pretendard" pitchFamily="34" charset="-122"/>
+                <a:cs typeface="Pretendard" pitchFamily="34" charset="-120"/>
               </a:rPr>
               <a:t>3</a:t>
             </a:r>
@@ -2900,9 +2900,9 @@
                 <a:solidFill>
                   <a:srgbClr val="1E3A8A"/>
                 </a:solidFill>
-                <a:latin typeface="Malgun Gothic" pitchFamily="34" charset="0"/>
-                <a:ea typeface="Malgun Gothic" pitchFamily="34" charset="-122"/>
-                <a:cs typeface="Malgun Gothic" pitchFamily="34" charset="-120"/>
+                <a:latin typeface="Pretendard" pitchFamily="34" charset="0"/>
+                <a:ea typeface="Pretendard" pitchFamily="34" charset="-122"/>
+                <a:cs typeface="Pretendard" pitchFamily="34" charset="-120"/>
               </a:rPr>
               <a:t>강점은 지키고, 키덜트·라이프스타일로 확장한다</a:t>
             </a:r>
@@ -2939,9 +2939,9 @@
                 <a:solidFill>
                   <a:srgbClr val="1F2937"/>
                 </a:solidFill>
-                <a:latin typeface="Malgun Gothic" pitchFamily="34" charset="0"/>
-                <a:ea typeface="Malgun Gothic" pitchFamily="34" charset="-122"/>
-                <a:cs typeface="Malgun Gothic" pitchFamily="34" charset="-120"/>
+                <a:latin typeface="Pretendard" pitchFamily="34" charset="0"/>
+                <a:ea typeface="Pretendard" pitchFamily="34" charset="-122"/>
+                <a:cs typeface="Pretendard" pitchFamily="34" charset="-120"/>
               </a:rPr>
               <a:t>동물 리얼리즘·베이비 경쟁력 유지 + 수집·착용형 신규 라인</a:t>
             </a:r>
@@ -2978,9 +2978,9 @@
                 <a:solidFill>
                   <a:srgbClr val="1F2937"/>
                 </a:solidFill>
-                <a:latin typeface="Malgun Gothic" pitchFamily="34" charset="0"/>
-                <a:ea typeface="Malgun Gothic" pitchFamily="34" charset="-122"/>
-                <a:cs typeface="Malgun Gothic" pitchFamily="34" charset="-120"/>
+                <a:latin typeface="Pretendard" pitchFamily="34" charset="0"/>
+                <a:ea typeface="Pretendard" pitchFamily="34" charset="-122"/>
+                <a:cs typeface="Pretendard" pitchFamily="34" charset="-120"/>
               </a:rPr>
               <a:t>글로벌 봉제완구 시장 </a:t>
             </a:r>
@@ -2992,9 +2992,9 @@
                 <a:solidFill>
                   <a:srgbClr val="DC2626"/>
                 </a:solidFill>
-                <a:latin typeface="Malgun Gothic" pitchFamily="34" charset="0"/>
-                <a:ea typeface="Malgun Gothic" pitchFamily="34" charset="-122"/>
-                <a:cs typeface="Malgun Gothic" pitchFamily="34" charset="-120"/>
+                <a:latin typeface="Pretendard" pitchFamily="34" charset="0"/>
+                <a:ea typeface="Pretendard" pitchFamily="34" charset="-122"/>
+                <a:cs typeface="Pretendard" pitchFamily="34" charset="-120"/>
               </a:rPr>
               <a:t>$13.7B (2025) → $25.9B (2033)</a:t>
             </a:r>
@@ -3006,9 +3006,9 @@
                 <a:solidFill>
                   <a:srgbClr val="1F2937"/>
                 </a:solidFill>
-                <a:latin typeface="Malgun Gothic" pitchFamily="34" charset="0"/>
-                <a:ea typeface="Malgun Gothic" pitchFamily="34" charset="-122"/>
-                <a:cs typeface="Malgun Gothic" pitchFamily="34" charset="-120"/>
+                <a:latin typeface="Pretendard" pitchFamily="34" charset="0"/>
+                <a:ea typeface="Pretendard" pitchFamily="34" charset="-122"/>
+                <a:cs typeface="Pretendard" pitchFamily="34" charset="-120"/>
               </a:rPr>
               <a:t>  ·  연평균 약 8%대 성장</a:t>
             </a:r>
@@ -3045,9 +3045,9 @@
                 <a:solidFill>
                   <a:srgbClr val="6B7280"/>
                 </a:solidFill>
-                <a:latin typeface="Malgun Gothic" pitchFamily="34" charset="0"/>
-                <a:ea typeface="Malgun Gothic" pitchFamily="34" charset="-122"/>
-                <a:cs typeface="Malgun Gothic" pitchFamily="34" charset="-120"/>
+                <a:latin typeface="Pretendard" pitchFamily="34" charset="0"/>
+                <a:ea typeface="Pretendard" pitchFamily="34" charset="-122"/>
+                <a:cs typeface="Pretendard" pitchFamily="34" charset="-120"/>
               </a:rPr>
               <a:t>2026. 08. 11. 기준   |   2</a:t>
             </a:r>
@@ -3116,9 +3116,9 @@
                 <a:solidFill>
                   <a:srgbClr val="1E3A8A"/>
                 </a:solidFill>
-                <a:latin typeface="Malgun Gothic" pitchFamily="34" charset="0"/>
-                <a:ea typeface="Malgun Gothic" pitchFamily="34" charset="-122"/>
-                <a:cs typeface="Malgun Gothic" pitchFamily="34" charset="-120"/>
+                <a:latin typeface="Pretendard" pitchFamily="34" charset="0"/>
+                <a:ea typeface="Pretendard" pitchFamily="34" charset="-122"/>
+                <a:cs typeface="Pretendard" pitchFamily="34" charset="-120"/>
               </a:rPr>
               <a:t>FRAMEWORK</a:t>
             </a:r>
@@ -3155,9 +3155,9 @@
                 <a:solidFill>
                   <a:srgbClr val="DC2626"/>
                 </a:solidFill>
-                <a:latin typeface="Malgun Gothic" pitchFamily="34" charset="0"/>
-                <a:ea typeface="Malgun Gothic" pitchFamily="34" charset="-122"/>
-                <a:cs typeface="Malgun Gothic" pitchFamily="34" charset="-120"/>
+                <a:latin typeface="NEXON Lv1 Gothic" pitchFamily="34" charset="0"/>
+                <a:ea typeface="NEXON Lv1 Gothic" pitchFamily="34" charset="-122"/>
+                <a:cs typeface="NEXON Lv1 Gothic" pitchFamily="34" charset="-120"/>
               </a:rPr>
               <a:t>4대 랭킹 지표, 무엇을 말하는가</a:t>
             </a:r>
@@ -3221,9 +3221,9 @@
                 <a:solidFill>
                   <a:srgbClr val="DC2626"/>
                 </a:solidFill>
-                <a:latin typeface="Malgun Gothic" pitchFamily="34" charset="0"/>
-                <a:ea typeface="Malgun Gothic" pitchFamily="34" charset="-122"/>
-                <a:cs typeface="Malgun Gothic" pitchFamily="34" charset="-120"/>
+                <a:latin typeface="Pretendard" pitchFamily="34" charset="0"/>
+                <a:ea typeface="Pretendard" pitchFamily="34" charset="-122"/>
+                <a:cs typeface="Pretendard" pitchFamily="34" charset="-120"/>
               </a:rPr>
               <a:t>BEST SELLERS</a:t>
             </a:r>
@@ -3260,9 +3260,9 @@
                 <a:solidFill>
                   <a:srgbClr val="1F2937"/>
                 </a:solidFill>
-                <a:latin typeface="Malgun Gothic" pitchFamily="34" charset="0"/>
-                <a:ea typeface="Malgun Gothic" pitchFamily="34" charset="-122"/>
-                <a:cs typeface="Malgun Gothic" pitchFamily="34" charset="-120"/>
+                <a:latin typeface="NEXON Lv1 Gothic" pitchFamily="34" charset="0"/>
+                <a:ea typeface="NEXON Lv1 Gothic" pitchFamily="34" charset="-122"/>
+                <a:cs typeface="NEXON Lv1 Gothic" pitchFamily="34" charset="-120"/>
               </a:rPr>
               <a:t>현재 판매 검증</a:t>
             </a:r>
@@ -3302,9 +3302,9 @@
                 <a:solidFill>
                   <a:srgbClr val="1F2937"/>
                 </a:solidFill>
-                <a:latin typeface="Malgun Gothic" pitchFamily="34" charset="0"/>
-                <a:ea typeface="Malgun Gothic" pitchFamily="34" charset="-122"/>
-                <a:cs typeface="Malgun Gothic" pitchFamily="34" charset="-120"/>
+                <a:latin typeface="Pretendard" pitchFamily="34" charset="0"/>
+                <a:ea typeface="Pretendard" pitchFamily="34" charset="-122"/>
+                <a:cs typeface="Pretendard" pitchFamily="34" charset="-120"/>
               </a:rPr>
               <a:t>지금 실제로 팔리는 상품</a:t>
             </a:r>
@@ -3322,9 +3322,9 @@
                 <a:solidFill>
                   <a:srgbClr val="1F2937"/>
                 </a:solidFill>
-                <a:latin typeface="Malgun Gothic" pitchFamily="34" charset="0"/>
-                <a:ea typeface="Malgun Gothic" pitchFamily="34" charset="-122"/>
-                <a:cs typeface="Malgun Gothic" pitchFamily="34" charset="-120"/>
+                <a:latin typeface="Pretendard" pitchFamily="34" charset="0"/>
+                <a:ea typeface="Pretendard" pitchFamily="34" charset="-122"/>
+                <a:cs typeface="Pretendard" pitchFamily="34" charset="-120"/>
               </a:rPr>
               <a:t>시간 단위로 갱신</a:t>
             </a:r>
@@ -3388,9 +3388,9 @@
                 <a:solidFill>
                   <a:srgbClr val="DC2626"/>
                 </a:solidFill>
-                <a:latin typeface="Malgun Gothic" pitchFamily="34" charset="0"/>
-                <a:ea typeface="Malgun Gothic" pitchFamily="34" charset="-122"/>
-                <a:cs typeface="Malgun Gothic" pitchFamily="34" charset="-120"/>
+                <a:latin typeface="Pretendard" pitchFamily="34" charset="0"/>
+                <a:ea typeface="Pretendard" pitchFamily="34" charset="-122"/>
+                <a:cs typeface="Pretendard" pitchFamily="34" charset="-120"/>
               </a:rPr>
               <a:t>MOVERS &amp; SHAKERS</a:t>
             </a:r>
@@ -3427,9 +3427,9 @@
                 <a:solidFill>
                   <a:srgbClr val="1F2937"/>
                 </a:solidFill>
-                <a:latin typeface="Malgun Gothic" pitchFamily="34" charset="0"/>
-                <a:ea typeface="Malgun Gothic" pitchFamily="34" charset="-122"/>
-                <a:cs typeface="Malgun Gothic" pitchFamily="34" charset="-120"/>
+                <a:latin typeface="NEXON Lv1 Gothic" pitchFamily="34" charset="0"/>
+                <a:ea typeface="NEXON Lv1 Gothic" pitchFamily="34" charset="-122"/>
+                <a:cs typeface="NEXON Lv1 Gothic" pitchFamily="34" charset="-120"/>
               </a:rPr>
               <a:t>단기 바이럴</a:t>
             </a:r>
@@ -3469,9 +3469,9 @@
                 <a:solidFill>
                   <a:srgbClr val="1F2937"/>
                 </a:solidFill>
-                <a:latin typeface="Malgun Gothic" pitchFamily="34" charset="0"/>
-                <a:ea typeface="Malgun Gothic" pitchFamily="34" charset="-122"/>
-                <a:cs typeface="Malgun Gothic" pitchFamily="34" charset="-120"/>
+                <a:latin typeface="Pretendard" pitchFamily="34" charset="0"/>
+                <a:ea typeface="Pretendard" pitchFamily="34" charset="-122"/>
+                <a:cs typeface="Pretendard" pitchFamily="34" charset="-120"/>
               </a:rPr>
               <a:t>최근 24시간 순위 상승폭</a:t>
             </a:r>
@@ -3489,9 +3489,9 @@
                 <a:solidFill>
                   <a:srgbClr val="1F2937"/>
                 </a:solidFill>
-                <a:latin typeface="Malgun Gothic" pitchFamily="34" charset="0"/>
-                <a:ea typeface="Malgun Gothic" pitchFamily="34" charset="-122"/>
-                <a:cs typeface="Malgun Gothic" pitchFamily="34" charset="-120"/>
+                <a:latin typeface="Pretendard" pitchFamily="34" charset="0"/>
+                <a:ea typeface="Pretendard" pitchFamily="34" charset="-122"/>
+                <a:cs typeface="Pretendard" pitchFamily="34" charset="-120"/>
               </a:rPr>
               <a:t>SNS·프로모션 반응</a:t>
             </a:r>
@@ -3555,9 +3555,9 @@
                 <a:solidFill>
                   <a:srgbClr val="1E3A8A"/>
                 </a:solidFill>
-                <a:latin typeface="Malgun Gothic" pitchFamily="34" charset="0"/>
-                <a:ea typeface="Malgun Gothic" pitchFamily="34" charset="-122"/>
-                <a:cs typeface="Malgun Gothic" pitchFamily="34" charset="-120"/>
+                <a:latin typeface="Pretendard" pitchFamily="34" charset="0"/>
+                <a:ea typeface="Pretendard" pitchFamily="34" charset="-122"/>
+                <a:cs typeface="Pretendard" pitchFamily="34" charset="-120"/>
               </a:rPr>
               <a:t>NEW RELEASES</a:t>
             </a:r>
@@ -3594,9 +3594,9 @@
                 <a:solidFill>
                   <a:srgbClr val="1F2937"/>
                 </a:solidFill>
-                <a:latin typeface="Malgun Gothic" pitchFamily="34" charset="0"/>
-                <a:ea typeface="Malgun Gothic" pitchFamily="34" charset="-122"/>
-                <a:cs typeface="Malgun Gothic" pitchFamily="34" charset="-120"/>
+                <a:latin typeface="NEXON Lv1 Gothic" pitchFamily="34" charset="0"/>
+                <a:ea typeface="NEXON Lv1 Gothic" pitchFamily="34" charset="-122"/>
+                <a:cs typeface="NEXON Lv1 Gothic" pitchFamily="34" charset="-120"/>
               </a:rPr>
               <a:t>신상품 초기 반응</a:t>
             </a:r>
@@ -3636,9 +3636,9 @@
                 <a:solidFill>
                   <a:srgbClr val="1F2937"/>
                 </a:solidFill>
-                <a:latin typeface="Malgun Gothic" pitchFamily="34" charset="0"/>
-                <a:ea typeface="Malgun Gothic" pitchFamily="34" charset="-122"/>
-                <a:cs typeface="Malgun Gothic" pitchFamily="34" charset="-120"/>
+                <a:latin typeface="Pretendard" pitchFamily="34" charset="0"/>
+                <a:ea typeface="Pretendard" pitchFamily="34" charset="-122"/>
+                <a:cs typeface="Pretendard" pitchFamily="34" charset="-120"/>
               </a:rPr>
               <a:t>출시·출시예정 신상품 중</a:t>
             </a:r>
@@ -3656,9 +3656,9 @@
                 <a:solidFill>
                   <a:srgbClr val="1F2937"/>
                 </a:solidFill>
-                <a:latin typeface="Malgun Gothic" pitchFamily="34" charset="0"/>
-                <a:ea typeface="Malgun Gothic" pitchFamily="34" charset="-122"/>
-                <a:cs typeface="Malgun Gothic" pitchFamily="34" charset="-120"/>
+                <a:latin typeface="Pretendard" pitchFamily="34" charset="0"/>
+                <a:ea typeface="Pretendard" pitchFamily="34" charset="-122"/>
+                <a:cs typeface="Pretendard" pitchFamily="34" charset="-120"/>
               </a:rPr>
               <a:t>판매 반응이 빠른 상품</a:t>
             </a:r>
@@ -3722,9 +3722,9 @@
                 <a:solidFill>
                   <a:srgbClr val="1E3A8A"/>
                 </a:solidFill>
-                <a:latin typeface="Malgun Gothic" pitchFamily="34" charset="0"/>
-                <a:ea typeface="Malgun Gothic" pitchFamily="34" charset="-122"/>
-                <a:cs typeface="Malgun Gothic" pitchFamily="34" charset="-120"/>
+                <a:latin typeface="Pretendard" pitchFamily="34" charset="0"/>
+                <a:ea typeface="Pretendard" pitchFamily="34" charset="-122"/>
+                <a:cs typeface="Pretendard" pitchFamily="34" charset="-120"/>
               </a:rPr>
               <a:t>MOST WISHED FOR</a:t>
             </a:r>
@@ -3761,9 +3761,9 @@
                 <a:solidFill>
                   <a:srgbClr val="1F2937"/>
                 </a:solidFill>
-                <a:latin typeface="Malgun Gothic" pitchFamily="34" charset="0"/>
-                <a:ea typeface="Malgun Gothic" pitchFamily="34" charset="-122"/>
-                <a:cs typeface="Malgun Gothic" pitchFamily="34" charset="-120"/>
+                <a:latin typeface="NEXON Lv1 Gothic" pitchFamily="34" charset="0"/>
+                <a:ea typeface="NEXON Lv1 Gothic" pitchFamily="34" charset="-122"/>
+                <a:cs typeface="NEXON Lv1 Gothic" pitchFamily="34" charset="-120"/>
               </a:rPr>
               <a:t>미래 구매 욕망</a:t>
             </a:r>
@@ -3803,9 +3803,9 @@
                 <a:solidFill>
                   <a:srgbClr val="1F2937"/>
                 </a:solidFill>
-                <a:latin typeface="Malgun Gothic" pitchFamily="34" charset="0"/>
-                <a:ea typeface="Malgun Gothic" pitchFamily="34" charset="-122"/>
-                <a:cs typeface="Malgun Gothic" pitchFamily="34" charset="-120"/>
+                <a:latin typeface="Pretendard" pitchFamily="34" charset="0"/>
+                <a:ea typeface="Pretendard" pitchFamily="34" charset="-122"/>
+                <a:cs typeface="Pretendard" pitchFamily="34" charset="-120"/>
               </a:rPr>
               <a:t>위시리스트·레지스트리</a:t>
             </a:r>
@@ -3823,9 +3823,9 @@
                 <a:solidFill>
                   <a:srgbClr val="1F2937"/>
                 </a:solidFill>
-                <a:latin typeface="Malgun Gothic" pitchFamily="34" charset="0"/>
-                <a:ea typeface="Malgun Gothic" pitchFamily="34" charset="-122"/>
-                <a:cs typeface="Malgun Gothic" pitchFamily="34" charset="-120"/>
+                <a:latin typeface="Pretendard" pitchFamily="34" charset="0"/>
+                <a:ea typeface="Pretendard" pitchFamily="34" charset="-122"/>
+                <a:cs typeface="Pretendard" pitchFamily="34" charset="-120"/>
               </a:rPr>
               <a:t>저장이 가장 많은 상품</a:t>
             </a:r>
@@ -3865,9 +3865,9 @@
                 <a:solidFill>
                   <a:srgbClr val="6B7280"/>
                 </a:solidFill>
-                <a:latin typeface="Malgun Gothic" pitchFamily="34" charset="0"/>
-                <a:ea typeface="Malgun Gothic" pitchFamily="34" charset="-122"/>
-                <a:cs typeface="Malgun Gothic" pitchFamily="34" charset="-120"/>
+                <a:latin typeface="Pretendard" pitchFamily="34" charset="0"/>
+                <a:ea typeface="Pretendard" pitchFamily="34" charset="-122"/>
+                <a:cs typeface="Pretendard" pitchFamily="34" charset="-120"/>
               </a:rPr>
               <a:t>※ Best Sellers Rank는 수시 갱신, Movers &amp; Shakers는 최근 24시간 기준 → 접속 시점·지역·재고에 따라 순위 상이</a:t>
             </a:r>
@@ -3904,9 +3904,9 @@
                 <a:solidFill>
                   <a:srgbClr val="6B7280"/>
                 </a:solidFill>
-                <a:latin typeface="Malgun Gothic" pitchFamily="34" charset="0"/>
-                <a:ea typeface="Malgun Gothic" pitchFamily="34" charset="-122"/>
-                <a:cs typeface="Malgun Gothic" pitchFamily="34" charset="-120"/>
+                <a:latin typeface="Pretendard" pitchFamily="34" charset="0"/>
+                <a:ea typeface="Pretendard" pitchFamily="34" charset="-122"/>
+                <a:cs typeface="Pretendard" pitchFamily="34" charset="-120"/>
               </a:rPr>
               <a:t>2026. 08. 11. 기준   |   3</a:t>
             </a:r>
@@ -3975,9 +3975,9 @@
                 <a:solidFill>
                   <a:srgbClr val="1E3A8A"/>
                 </a:solidFill>
-                <a:latin typeface="Malgun Gothic" pitchFamily="34" charset="0"/>
-                <a:ea typeface="Malgun Gothic" pitchFamily="34" charset="-122"/>
-                <a:cs typeface="Malgun Gothic" pitchFamily="34" charset="-120"/>
+                <a:latin typeface="Pretendard" pitchFamily="34" charset="0"/>
+                <a:ea typeface="Pretendard" pitchFamily="34" charset="-122"/>
+                <a:cs typeface="Pretendard" pitchFamily="34" charset="-120"/>
               </a:rPr>
               <a:t>CROSS ANALYSIS</a:t>
             </a:r>
@@ -4014,9 +4014,9 @@
                 <a:solidFill>
                   <a:srgbClr val="DC2626"/>
                 </a:solidFill>
-                <a:latin typeface="Malgun Gothic" pitchFamily="34" charset="0"/>
-                <a:ea typeface="Malgun Gothic" pitchFamily="34" charset="-122"/>
-                <a:cs typeface="Malgun Gothic" pitchFamily="34" charset="-120"/>
+                <a:latin typeface="NEXON Lv1 Gothic" pitchFamily="34" charset="0"/>
+                <a:ea typeface="NEXON Lv1 Gothic" pitchFamily="34" charset="-122"/>
+                <a:cs typeface="NEXON Lv1 Gothic" pitchFamily="34" charset="-120"/>
               </a:rPr>
               <a:t>교차하면 기획 판단이 나온다</a:t>
             </a:r>
@@ -4105,9 +4105,9 @@
                 <a:solidFill>
                   <a:srgbClr val="DC2626"/>
                 </a:solidFill>
-                <a:latin typeface="Malgun Gothic" pitchFamily="34" charset="0"/>
-                <a:ea typeface="Malgun Gothic" pitchFamily="34" charset="-122"/>
-                <a:cs typeface="Malgun Gothic" pitchFamily="34" charset="-120"/>
+                <a:latin typeface="Pretendard" pitchFamily="34" charset="0"/>
+                <a:ea typeface="Pretendard" pitchFamily="34" charset="-122"/>
+                <a:cs typeface="Pretendard" pitchFamily="34" charset="-120"/>
               </a:rPr>
               <a:t>BEST + WISHED</a:t>
             </a:r>
@@ -4144,9 +4144,9 @@
                 <a:solidFill>
                   <a:srgbClr val="6B7280"/>
                 </a:solidFill>
-                <a:latin typeface="Malgun Gothic" pitchFamily="34" charset="0"/>
-                <a:ea typeface="Malgun Gothic" pitchFamily="34" charset="-122"/>
-                <a:cs typeface="Malgun Gothic" pitchFamily="34" charset="-120"/>
+                <a:latin typeface="Pretendard" pitchFamily="34" charset="0"/>
+                <a:ea typeface="Pretendard" pitchFamily="34" charset="-122"/>
+                <a:cs typeface="Pretendard" pitchFamily="34" charset="-120"/>
               </a:rPr>
               <a:t>→</a:t>
             </a:r>
@@ -4183,9 +4183,9 @@
                 <a:solidFill>
                   <a:srgbClr val="1F2937"/>
                 </a:solidFill>
-                <a:latin typeface="Malgun Gothic" pitchFamily="34" charset="0"/>
-                <a:ea typeface="Malgun Gothic" pitchFamily="34" charset="-122"/>
-                <a:cs typeface="Malgun Gothic" pitchFamily="34" charset="-120"/>
+                <a:latin typeface="Pretendard" pitchFamily="34" charset="0"/>
+                <a:ea typeface="Pretendard" pitchFamily="34" charset="-122"/>
+                <a:cs typeface="Pretendard" pitchFamily="34" charset="-120"/>
               </a:rPr>
               <a:t>안정 SKU · 기본 라인업화, 재고 확대</a:t>
             </a:r>
@@ -4274,9 +4274,9 @@
                 <a:solidFill>
                   <a:srgbClr val="DC2626"/>
                 </a:solidFill>
-                <a:latin typeface="Malgun Gothic" pitchFamily="34" charset="0"/>
-                <a:ea typeface="Malgun Gothic" pitchFamily="34" charset="-122"/>
-                <a:cs typeface="Malgun Gothic" pitchFamily="34" charset="-120"/>
+                <a:latin typeface="Pretendard" pitchFamily="34" charset="0"/>
+                <a:ea typeface="Pretendard" pitchFamily="34" charset="-122"/>
+                <a:cs typeface="Pretendard" pitchFamily="34" charset="-120"/>
               </a:rPr>
               <a:t>BEST + NEW</a:t>
             </a:r>
@@ -4313,9 +4313,9 @@
                 <a:solidFill>
                   <a:srgbClr val="6B7280"/>
                 </a:solidFill>
-                <a:latin typeface="Malgun Gothic" pitchFamily="34" charset="0"/>
-                <a:ea typeface="Malgun Gothic" pitchFamily="34" charset="-122"/>
-                <a:cs typeface="Malgun Gothic" pitchFamily="34" charset="-120"/>
+                <a:latin typeface="Pretendard" pitchFamily="34" charset="0"/>
+                <a:ea typeface="Pretendard" pitchFamily="34" charset="-122"/>
+                <a:cs typeface="Pretendard" pitchFamily="34" charset="-120"/>
               </a:rPr>
               <a:t>→</a:t>
             </a:r>
@@ -4352,9 +4352,9 @@
                 <a:solidFill>
                   <a:srgbClr val="1F2937"/>
                 </a:solidFill>
-                <a:latin typeface="Malgun Gothic" pitchFamily="34" charset="0"/>
-                <a:ea typeface="Malgun Gothic" pitchFamily="34" charset="-122"/>
-                <a:cs typeface="Malgun Gothic" pitchFamily="34" charset="-120"/>
+                <a:latin typeface="Pretendard" pitchFamily="34" charset="0"/>
+                <a:ea typeface="Pretendard" pitchFamily="34" charset="-122"/>
+                <a:cs typeface="Pretendard" pitchFamily="34" charset="-120"/>
               </a:rPr>
               <a:t>차별화 소재·동물·사이즈로 후속 개발</a:t>
             </a:r>
@@ -4443,9 +4443,9 @@
                 <a:solidFill>
                   <a:srgbClr val="DC2626"/>
                 </a:solidFill>
-                <a:latin typeface="Malgun Gothic" pitchFamily="34" charset="0"/>
-                <a:ea typeface="Malgun Gothic" pitchFamily="34" charset="-122"/>
-                <a:cs typeface="Malgun Gothic" pitchFamily="34" charset="-120"/>
+                <a:latin typeface="Pretendard" pitchFamily="34" charset="0"/>
+                <a:ea typeface="Pretendard" pitchFamily="34" charset="-122"/>
+                <a:cs typeface="Pretendard" pitchFamily="34" charset="-120"/>
               </a:rPr>
               <a:t>MOVERS + WISHED</a:t>
             </a:r>
@@ -4482,9 +4482,9 @@
                 <a:solidFill>
                   <a:srgbClr val="6B7280"/>
                 </a:solidFill>
-                <a:latin typeface="Malgun Gothic" pitchFamily="34" charset="0"/>
-                <a:ea typeface="Malgun Gothic" pitchFamily="34" charset="-122"/>
-                <a:cs typeface="Malgun Gothic" pitchFamily="34" charset="-120"/>
+                <a:latin typeface="Pretendard" pitchFamily="34" charset="0"/>
+                <a:ea typeface="Pretendard" pitchFamily="34" charset="-122"/>
+                <a:cs typeface="Pretendard" pitchFamily="34" charset="-120"/>
               </a:rPr>
               <a:t>→</a:t>
             </a:r>
@@ -4521,9 +4521,9 @@
                 <a:solidFill>
                   <a:srgbClr val="1F2937"/>
                 </a:solidFill>
-                <a:latin typeface="Malgun Gothic" pitchFamily="34" charset="0"/>
-                <a:ea typeface="Malgun Gothic" pitchFamily="34" charset="-122"/>
-                <a:cs typeface="Malgun Gothic" pitchFamily="34" charset="-120"/>
+                <a:latin typeface="Pretendard" pitchFamily="34" charset="0"/>
+                <a:ea typeface="Pretendard" pitchFamily="34" charset="-122"/>
+                <a:cs typeface="Pretendard" pitchFamily="34" charset="-120"/>
               </a:rPr>
               <a:t>숏폼·인플루언서·팝업 테스트 상품</a:t>
             </a:r>
@@ -4612,9 +4612,9 @@
                 <a:solidFill>
                   <a:srgbClr val="1E3A8A"/>
                 </a:solidFill>
-                <a:latin typeface="Malgun Gothic" pitchFamily="34" charset="0"/>
-                <a:ea typeface="Malgun Gothic" pitchFamily="34" charset="-122"/>
-                <a:cs typeface="Malgun Gothic" pitchFamily="34" charset="-120"/>
+                <a:latin typeface="Pretendard" pitchFamily="34" charset="0"/>
+                <a:ea typeface="Pretendard" pitchFamily="34" charset="-122"/>
+                <a:cs typeface="Pretendard" pitchFamily="34" charset="-120"/>
               </a:rPr>
               <a:t>NEW + WISHED</a:t>
             </a:r>
@@ -4651,9 +4651,9 @@
                 <a:solidFill>
                   <a:srgbClr val="6B7280"/>
                 </a:solidFill>
-                <a:latin typeface="Malgun Gothic" pitchFamily="34" charset="0"/>
-                <a:ea typeface="Malgun Gothic" pitchFamily="34" charset="-122"/>
-                <a:cs typeface="Malgun Gothic" pitchFamily="34" charset="-120"/>
+                <a:latin typeface="Pretendard" pitchFamily="34" charset="0"/>
+                <a:ea typeface="Pretendard" pitchFamily="34" charset="-122"/>
+                <a:cs typeface="Pretendard" pitchFamily="34" charset="-120"/>
               </a:rPr>
               <a:t>→</a:t>
             </a:r>
@@ -4690,9 +4690,9 @@
                 <a:solidFill>
                   <a:srgbClr val="1F2937"/>
                 </a:solidFill>
-                <a:latin typeface="Malgun Gothic" pitchFamily="34" charset="0"/>
-                <a:ea typeface="Malgun Gothic" pitchFamily="34" charset="-122"/>
-                <a:cs typeface="Malgun Gothic" pitchFamily="34" charset="-120"/>
+                <a:latin typeface="Pretendard" pitchFamily="34" charset="0"/>
+                <a:ea typeface="Pretendard" pitchFamily="34" charset="-122"/>
+                <a:cs typeface="Pretendard" pitchFamily="34" charset="-120"/>
               </a:rPr>
               <a:t>6~12개월 선행 기획 후보</a:t>
             </a:r>
@@ -4781,9 +4781,9 @@
                 <a:solidFill>
                   <a:srgbClr val="1F2937"/>
                 </a:solidFill>
-                <a:latin typeface="Malgun Gothic" pitchFamily="34" charset="0"/>
-                <a:ea typeface="Malgun Gothic" pitchFamily="34" charset="-122"/>
-                <a:cs typeface="Malgun Gothic" pitchFamily="34" charset="-120"/>
+                <a:latin typeface="Pretendard" pitchFamily="34" charset="0"/>
+                <a:ea typeface="Pretendard" pitchFamily="34" charset="-122"/>
+                <a:cs typeface="Pretendard" pitchFamily="34" charset="-120"/>
               </a:rPr>
               <a:t>MOVERS 단독</a:t>
             </a:r>
@@ -4820,9 +4820,9 @@
                 <a:solidFill>
                   <a:srgbClr val="6B7280"/>
                 </a:solidFill>
-                <a:latin typeface="Malgun Gothic" pitchFamily="34" charset="0"/>
-                <a:ea typeface="Malgun Gothic" pitchFamily="34" charset="-122"/>
-                <a:cs typeface="Malgun Gothic" pitchFamily="34" charset="-120"/>
+                <a:latin typeface="Pretendard" pitchFamily="34" charset="0"/>
+                <a:ea typeface="Pretendard" pitchFamily="34" charset="-122"/>
+                <a:cs typeface="Pretendard" pitchFamily="34" charset="-120"/>
               </a:rPr>
               <a:t>→</a:t>
             </a:r>
@@ -4859,9 +4859,9 @@
                 <a:solidFill>
                   <a:srgbClr val="1F2937"/>
                 </a:solidFill>
-                <a:latin typeface="Malgun Gothic" pitchFamily="34" charset="0"/>
-                <a:ea typeface="Malgun Gothic" pitchFamily="34" charset="-122"/>
-                <a:cs typeface="Malgun Gothic" pitchFamily="34" charset="-120"/>
+                <a:latin typeface="Pretendard" pitchFamily="34" charset="0"/>
+                <a:ea typeface="Pretendard" pitchFamily="34" charset="-122"/>
+                <a:cs typeface="Pretendard" pitchFamily="34" charset="-120"/>
               </a:rPr>
               <a:t>일시적 프로모션 — 대량 개발 보류</a:t>
             </a:r>
@@ -4950,9 +4950,9 @@
                 <a:solidFill>
                   <a:srgbClr val="1E3A8A"/>
                 </a:solidFill>
-                <a:latin typeface="Malgun Gothic" pitchFamily="34" charset="0"/>
-                <a:ea typeface="Malgun Gothic" pitchFamily="34" charset="-122"/>
-                <a:cs typeface="Malgun Gothic" pitchFamily="34" charset="-120"/>
+                <a:latin typeface="Pretendard" pitchFamily="34" charset="0"/>
+                <a:ea typeface="Pretendard" pitchFamily="34" charset="-122"/>
+                <a:cs typeface="Pretendard" pitchFamily="34" charset="-120"/>
               </a:rPr>
               <a:t>WISHED ↑ · BEST ↓</a:t>
             </a:r>
@@ -4989,9 +4989,9 @@
                 <a:solidFill>
                   <a:srgbClr val="6B7280"/>
                 </a:solidFill>
-                <a:latin typeface="Malgun Gothic" pitchFamily="34" charset="0"/>
-                <a:ea typeface="Malgun Gothic" pitchFamily="34" charset="-122"/>
-                <a:cs typeface="Malgun Gothic" pitchFamily="34" charset="-120"/>
+                <a:latin typeface="Pretendard" pitchFamily="34" charset="0"/>
+                <a:ea typeface="Pretendard" pitchFamily="34" charset="-122"/>
+                <a:cs typeface="Pretendard" pitchFamily="34" charset="-120"/>
               </a:rPr>
               <a:t>→</a:t>
             </a:r>
@@ -5028,9 +5028,9 @@
                 <a:solidFill>
                   <a:srgbClr val="1F2937"/>
                 </a:solidFill>
-                <a:latin typeface="Malgun Gothic" pitchFamily="34" charset="0"/>
-                <a:ea typeface="Malgun Gothic" pitchFamily="34" charset="-122"/>
-                <a:cs typeface="Malgun Gothic" pitchFamily="34" charset="-120"/>
+                <a:latin typeface="Pretendard" pitchFamily="34" charset="0"/>
+                <a:ea typeface="Pretendard" pitchFamily="34" charset="-122"/>
+                <a:cs typeface="Pretendard" pitchFamily="34" charset="-120"/>
               </a:rPr>
               <a:t>가격·재고 장벽 → 프리미엄 선물형</a:t>
             </a:r>
@@ -5067,9 +5067,9 @@
                 <a:solidFill>
                   <a:srgbClr val="6B7280"/>
                 </a:solidFill>
-                <a:latin typeface="Malgun Gothic" pitchFamily="34" charset="0"/>
-                <a:ea typeface="Malgun Gothic" pitchFamily="34" charset="-122"/>
-                <a:cs typeface="Malgun Gothic" pitchFamily="34" charset="-120"/>
+                <a:latin typeface="Pretendard" pitchFamily="34" charset="0"/>
+                <a:ea typeface="Pretendard" pitchFamily="34" charset="-122"/>
+                <a:cs typeface="Pretendard" pitchFamily="34" charset="-120"/>
               </a:rPr>
               <a:t>2026. 08. 11. 기준   |   4</a:t>
             </a:r>
@@ -5138,9 +5138,9 @@
                 <a:solidFill>
                   <a:srgbClr val="1E3A8A"/>
                 </a:solidFill>
-                <a:latin typeface="Malgun Gothic" pitchFamily="34" charset="0"/>
-                <a:ea typeface="Malgun Gothic" pitchFamily="34" charset="-122"/>
-                <a:cs typeface="Malgun Gothic" pitchFamily="34" charset="-120"/>
+                <a:latin typeface="Pretendard" pitchFamily="34" charset="0"/>
+                <a:ea typeface="Pretendard" pitchFamily="34" charset="-122"/>
+                <a:cs typeface="Pretendard" pitchFamily="34" charset="-120"/>
               </a:rPr>
               <a:t>MARKET SIGNAL</a:t>
             </a:r>
@@ -5177,9 +5177,9 @@
                 <a:solidFill>
                   <a:srgbClr val="DC2626"/>
                 </a:solidFill>
-                <a:latin typeface="Malgun Gothic" pitchFamily="34" charset="0"/>
-                <a:ea typeface="Malgun Gothic" pitchFamily="34" charset="-122"/>
-                <a:cs typeface="Malgun Gothic" pitchFamily="34" charset="-120"/>
+                <a:latin typeface="NEXON Lv1 Gothic" pitchFamily="34" charset="0"/>
+                <a:ea typeface="NEXON Lv1 Gothic" pitchFamily="34" charset="-122"/>
+                <a:cs typeface="NEXON Lv1 Gothic" pitchFamily="34" charset="-120"/>
               </a:rPr>
               <a:t>랭킹에서 읽히는 성장 상품군</a:t>
             </a:r>
@@ -5268,9 +5268,9 @@
                 <a:solidFill>
                   <a:srgbClr val="FFFFFF"/>
                 </a:solidFill>
-                <a:latin typeface="Malgun Gothic" pitchFamily="34" charset="0"/>
-                <a:ea typeface="Malgun Gothic" pitchFamily="34" charset="-122"/>
-                <a:cs typeface="Malgun Gothic" pitchFamily="34" charset="-120"/>
+                <a:latin typeface="Pretendard" pitchFamily="34" charset="0"/>
+                <a:ea typeface="Pretendard" pitchFamily="34" charset="-122"/>
+                <a:cs typeface="Pretendard" pitchFamily="34" charset="-120"/>
               </a:rPr>
               <a:t>1</a:t>
             </a:r>
@@ -5307,9 +5307,9 @@
                 <a:solidFill>
                   <a:srgbClr val="1F2937"/>
                 </a:solidFill>
-                <a:latin typeface="Malgun Gothic" pitchFamily="34" charset="0"/>
-                <a:ea typeface="Malgun Gothic" pitchFamily="34" charset="-122"/>
-                <a:cs typeface="Malgun Gothic" pitchFamily="34" charset="-120"/>
+                <a:latin typeface="Pretendard" pitchFamily="34" charset="0"/>
+                <a:ea typeface="Pretendard" pitchFamily="34" charset="-122"/>
+                <a:cs typeface="Pretendard" pitchFamily="34" charset="-120"/>
               </a:rPr>
               <a:t>미니 플러시 · 클립온 · 백참</a:t>
             </a:r>
@@ -5398,9 +5398,9 @@
                 <a:solidFill>
                   <a:srgbClr val="FFFFFF"/>
                 </a:solidFill>
-                <a:latin typeface="Malgun Gothic" pitchFamily="34" charset="0"/>
-                <a:ea typeface="Malgun Gothic" pitchFamily="34" charset="-122"/>
-                <a:cs typeface="Malgun Gothic" pitchFamily="34" charset="-120"/>
+                <a:latin typeface="Pretendard" pitchFamily="34" charset="0"/>
+                <a:ea typeface="Pretendard" pitchFamily="34" charset="-122"/>
+                <a:cs typeface="Pretendard" pitchFamily="34" charset="-120"/>
               </a:rPr>
               <a:t>2</a:t>
             </a:r>
@@ -5437,9 +5437,9 @@
                 <a:solidFill>
                   <a:srgbClr val="1F2937"/>
                 </a:solidFill>
-                <a:latin typeface="Malgun Gothic" pitchFamily="34" charset="0"/>
-                <a:ea typeface="Malgun Gothic" pitchFamily="34" charset="-122"/>
-                <a:cs typeface="Malgun Gothic" pitchFamily="34" charset="-120"/>
+                <a:latin typeface="Pretendard" pitchFamily="34" charset="0"/>
+                <a:ea typeface="Pretendard" pitchFamily="34" charset="-122"/>
+                <a:cs typeface="Pretendard" pitchFamily="34" charset="-120"/>
               </a:rPr>
               <a:t>블라인드박스형 봉제 굿즈</a:t>
             </a:r>
@@ -5528,9 +5528,9 @@
                 <a:solidFill>
                   <a:srgbClr val="FFFFFF"/>
                 </a:solidFill>
-                <a:latin typeface="Malgun Gothic" pitchFamily="34" charset="0"/>
-                <a:ea typeface="Malgun Gothic" pitchFamily="34" charset="-122"/>
-                <a:cs typeface="Malgun Gothic" pitchFamily="34" charset="-120"/>
+                <a:latin typeface="Pretendard" pitchFamily="34" charset="0"/>
+                <a:ea typeface="Pretendard" pitchFamily="34" charset="-122"/>
+                <a:cs typeface="Pretendard" pitchFamily="34" charset="-120"/>
               </a:rPr>
               <a:t>3</a:t>
             </a:r>
@@ -5567,9 +5567,9 @@
                 <a:solidFill>
                   <a:srgbClr val="1F2937"/>
                 </a:solidFill>
-                <a:latin typeface="Malgun Gothic" pitchFamily="34" charset="0"/>
-                <a:ea typeface="Malgun Gothic" pitchFamily="34" charset="-122"/>
-                <a:cs typeface="Malgun Gothic" pitchFamily="34" charset="-120"/>
+                <a:latin typeface="Pretendard" pitchFamily="34" charset="0"/>
+                <a:ea typeface="Pretendard" pitchFamily="34" charset="-122"/>
+                <a:cs typeface="Pretendard" pitchFamily="34" charset="-120"/>
               </a:rPr>
               <a:t>힐링 · 수면 · 온열 기능성</a:t>
             </a:r>
@@ -5658,9 +5658,9 @@
                 <a:solidFill>
                   <a:srgbClr val="FFFFFF"/>
                 </a:solidFill>
-                <a:latin typeface="Malgun Gothic" pitchFamily="34" charset="0"/>
-                <a:ea typeface="Malgun Gothic" pitchFamily="34" charset="-122"/>
-                <a:cs typeface="Malgun Gothic" pitchFamily="34" charset="-120"/>
+                <a:latin typeface="Pretendard" pitchFamily="34" charset="0"/>
+                <a:ea typeface="Pretendard" pitchFamily="34" charset="-122"/>
+                <a:cs typeface="Pretendard" pitchFamily="34" charset="-120"/>
               </a:rPr>
               <a:t>4</a:t>
             </a:r>
@@ -5697,9 +5697,9 @@
                 <a:solidFill>
                   <a:srgbClr val="1F2937"/>
                 </a:solidFill>
-                <a:latin typeface="Malgun Gothic" pitchFamily="34" charset="0"/>
-                <a:ea typeface="Malgun Gothic" pitchFamily="34" charset="-122"/>
-                <a:cs typeface="Malgun Gothic" pitchFamily="34" charset="-120"/>
+                <a:latin typeface="Pretendard" pitchFamily="34" charset="0"/>
+                <a:ea typeface="Pretendard" pitchFamily="34" charset="-122"/>
+                <a:cs typeface="Pretendard" pitchFamily="34" charset="-120"/>
               </a:rPr>
               <a:t>어글리 큐트 캐릭터</a:t>
             </a:r>
@@ -5788,9 +5788,9 @@
                 <a:solidFill>
                   <a:srgbClr val="FFFFFF"/>
                 </a:solidFill>
-                <a:latin typeface="Malgun Gothic" pitchFamily="34" charset="0"/>
-                <a:ea typeface="Malgun Gothic" pitchFamily="34" charset="-122"/>
-                <a:cs typeface="Malgun Gothic" pitchFamily="34" charset="-120"/>
+                <a:latin typeface="Pretendard" pitchFamily="34" charset="0"/>
+                <a:ea typeface="Pretendard" pitchFamily="34" charset="-122"/>
+                <a:cs typeface="Pretendard" pitchFamily="34" charset="-120"/>
               </a:rPr>
               <a:t>5</a:t>
             </a:r>
@@ -5827,9 +5827,9 @@
                 <a:solidFill>
                   <a:srgbClr val="1F2937"/>
                 </a:solidFill>
-                <a:latin typeface="Malgun Gothic" pitchFamily="34" charset="0"/>
-                <a:ea typeface="Malgun Gothic" pitchFamily="34" charset="-122"/>
-                <a:cs typeface="Malgun Gothic" pitchFamily="34" charset="-120"/>
+                <a:latin typeface="Pretendard" pitchFamily="34" charset="0"/>
+                <a:ea typeface="Pretendard" pitchFamily="34" charset="-122"/>
+                <a:cs typeface="Pretendard" pitchFamily="34" charset="-120"/>
               </a:rPr>
               <a:t>리얼리즘 동물 plush</a:t>
             </a:r>
@@ -5918,9 +5918,9 @@
                 <a:solidFill>
                   <a:srgbClr val="FFFFFF"/>
                 </a:solidFill>
-                <a:latin typeface="Malgun Gothic" pitchFamily="34" charset="0"/>
-                <a:ea typeface="Malgun Gothic" pitchFamily="34" charset="-122"/>
-                <a:cs typeface="Malgun Gothic" pitchFamily="34" charset="-120"/>
+                <a:latin typeface="Pretendard" pitchFamily="34" charset="0"/>
+                <a:ea typeface="Pretendard" pitchFamily="34" charset="-122"/>
+                <a:cs typeface="Pretendard" pitchFamily="34" charset="-120"/>
               </a:rPr>
               <a:t>6</a:t>
             </a:r>
@@ -5957,9 +5957,9 @@
                 <a:solidFill>
                   <a:srgbClr val="1F2937"/>
                 </a:solidFill>
-                <a:latin typeface="Malgun Gothic" pitchFamily="34" charset="0"/>
-                <a:ea typeface="Malgun Gothic" pitchFamily="34" charset="-122"/>
-                <a:cs typeface="Malgun Gothic" pitchFamily="34" charset="-120"/>
+                <a:latin typeface="Pretendard" pitchFamily="34" charset="0"/>
+                <a:ea typeface="Pretendard" pitchFamily="34" charset="-122"/>
+                <a:cs typeface="Pretendard" pitchFamily="34" charset="-120"/>
               </a:rPr>
               <a:t>베이비 센서리 plush</a:t>
             </a:r>
@@ -6048,9 +6048,9 @@
                 <a:solidFill>
                   <a:srgbClr val="FFFFFF"/>
                 </a:solidFill>
-                <a:latin typeface="Malgun Gothic" pitchFamily="34" charset="0"/>
-                <a:ea typeface="Malgun Gothic" pitchFamily="34" charset="-122"/>
-                <a:cs typeface="Malgun Gothic" pitchFamily="34" charset="-120"/>
+                <a:latin typeface="Pretendard" pitchFamily="34" charset="0"/>
+                <a:ea typeface="Pretendard" pitchFamily="34" charset="-122"/>
+                <a:cs typeface="Pretendard" pitchFamily="34" charset="-120"/>
               </a:rPr>
               <a:t>7</a:t>
             </a:r>
@@ -6087,9 +6087,9 @@
                 <a:solidFill>
                   <a:srgbClr val="1F2937"/>
                 </a:solidFill>
-                <a:latin typeface="Malgun Gothic" pitchFamily="34" charset="0"/>
-                <a:ea typeface="Malgun Gothic" pitchFamily="34" charset="-122"/>
-                <a:cs typeface="Malgun Gothic" pitchFamily="34" charset="-120"/>
+                <a:latin typeface="Pretendard" pitchFamily="34" charset="0"/>
+                <a:ea typeface="Pretendard" pitchFamily="34" charset="-122"/>
+                <a:cs typeface="Pretendard" pitchFamily="34" charset="-120"/>
               </a:rPr>
               <a:t>푸드 · 디저트 plush</a:t>
             </a:r>
@@ -6178,9 +6178,9 @@
                 <a:solidFill>
                   <a:srgbClr val="FFFFFF"/>
                 </a:solidFill>
-                <a:latin typeface="Malgun Gothic" pitchFamily="34" charset="0"/>
-                <a:ea typeface="Malgun Gothic" pitchFamily="34" charset="-122"/>
-                <a:cs typeface="Malgun Gothic" pitchFamily="34" charset="-120"/>
+                <a:latin typeface="Pretendard" pitchFamily="34" charset="0"/>
+                <a:ea typeface="Pretendard" pitchFamily="34" charset="-122"/>
+                <a:cs typeface="Pretendard" pitchFamily="34" charset="-120"/>
               </a:rPr>
               <a:t>8</a:t>
             </a:r>
@@ -6217,9 +6217,9 @@
                 <a:solidFill>
                   <a:srgbClr val="1F2937"/>
                 </a:solidFill>
-                <a:latin typeface="Malgun Gothic" pitchFamily="34" charset="0"/>
-                <a:ea typeface="Malgun Gothic" pitchFamily="34" charset="-122"/>
-                <a:cs typeface="Malgun Gothic" pitchFamily="34" charset="-120"/>
+                <a:latin typeface="Pretendard" pitchFamily="34" charset="0"/>
+                <a:ea typeface="Pretendard" pitchFamily="34" charset="-122"/>
+                <a:cs typeface="Pretendard" pitchFamily="34" charset="-120"/>
               </a:rPr>
               <a:t>외부 IP 콜라보 plush</a:t>
             </a:r>
@@ -6259,9 +6259,9 @@
                 <a:solidFill>
                   <a:srgbClr val="6B7280"/>
                 </a:solidFill>
-                <a:latin typeface="Malgun Gothic" pitchFamily="34" charset="0"/>
-                <a:ea typeface="Malgun Gothic" pitchFamily="34" charset="-122"/>
-                <a:cs typeface="Malgun Gothic" pitchFamily="34" charset="-120"/>
+                <a:latin typeface="Pretendard" pitchFamily="34" charset="0"/>
+                <a:ea typeface="Pretendard" pitchFamily="34" charset="-122"/>
+                <a:cs typeface="Pretendard" pitchFamily="34" charset="-120"/>
               </a:rPr>
               <a:t>1~4 : 신규 확장 영역(키덜트·수집·감성 케어)   |   5~8 : 오로라 기존 강점 기반 심화 영역</a:t>
             </a:r>
@@ -6298,9 +6298,9 @@
                 <a:solidFill>
                   <a:srgbClr val="6B7280"/>
                 </a:solidFill>
-                <a:latin typeface="Malgun Gothic" pitchFamily="34" charset="0"/>
-                <a:ea typeface="Malgun Gothic" pitchFamily="34" charset="-122"/>
-                <a:cs typeface="Malgun Gothic" pitchFamily="34" charset="-120"/>
+                <a:latin typeface="Pretendard" pitchFamily="34" charset="0"/>
+                <a:ea typeface="Pretendard" pitchFamily="34" charset="-122"/>
+                <a:cs typeface="Pretendard" pitchFamily="34" charset="-120"/>
               </a:rPr>
               <a:t>2026. 08. 11. 기준   |   5</a:t>
             </a:r>
@@ -6369,9 +6369,9 @@
                 <a:solidFill>
                   <a:srgbClr val="1E3A8A"/>
                 </a:solidFill>
-                <a:latin typeface="Malgun Gothic" pitchFamily="34" charset="0"/>
-                <a:ea typeface="Malgun Gothic" pitchFamily="34" charset="-122"/>
-                <a:cs typeface="Malgun Gothic" pitchFamily="34" charset="-120"/>
+                <a:latin typeface="Pretendard" pitchFamily="34" charset="0"/>
+                <a:ea typeface="Pretendard" pitchFamily="34" charset="-122"/>
+                <a:cs typeface="Pretendard" pitchFamily="34" charset="-120"/>
               </a:rPr>
               <a:t>BRAND MAPPING</a:t>
             </a:r>
@@ -6408,9 +6408,9 @@
                 <a:solidFill>
                   <a:srgbClr val="DC2626"/>
                 </a:solidFill>
-                <a:latin typeface="Malgun Gothic" pitchFamily="34" charset="0"/>
-                <a:ea typeface="Malgun Gothic" pitchFamily="34" charset="-122"/>
-                <a:cs typeface="Malgun Gothic" pitchFamily="34" charset="-120"/>
+                <a:latin typeface="NEXON Lv1 Gothic" pitchFamily="34" charset="0"/>
+                <a:ea typeface="NEXON Lv1 Gothic" pitchFamily="34" charset="-122"/>
+                <a:cs typeface="NEXON Lv1 Gothic" pitchFamily="34" charset="-120"/>
               </a:rPr>
               <a:t>브랜드 분류 정정</a:t>
             </a:r>
@@ -6474,9 +6474,9 @@
                 <a:solidFill>
                   <a:srgbClr val="1E3A8A"/>
                 </a:solidFill>
-                <a:latin typeface="Malgun Gothic" pitchFamily="34" charset="0"/>
-                <a:ea typeface="Malgun Gothic" pitchFamily="34" charset="-122"/>
-                <a:cs typeface="Malgun Gothic" pitchFamily="34" charset="-120"/>
+                <a:latin typeface="NEXON Lv1 Gothic" pitchFamily="34" charset="0"/>
+                <a:ea typeface="NEXON Lv1 Gothic" pitchFamily="34" charset="-122"/>
+                <a:cs typeface="NEXON Lv1 Gothic" pitchFamily="34" charset="-120"/>
               </a:rPr>
               <a:t>오로라월드 자사 브랜드</a:t>
             </a:r>
@@ -6513,9 +6513,9 @@
                 <a:solidFill>
                   <a:srgbClr val="1F2937"/>
                 </a:solidFill>
-                <a:latin typeface="Malgun Gothic" pitchFamily="34" charset="0"/>
-                <a:ea typeface="Malgun Gothic" pitchFamily="34" charset="-122"/>
-                <a:cs typeface="Malgun Gothic" pitchFamily="34" charset="-120"/>
+                <a:latin typeface="Pretendard" pitchFamily="34" charset="0"/>
+                <a:ea typeface="Pretendard" pitchFamily="34" charset="-122"/>
+                <a:cs typeface="Pretendard" pitchFamily="34" charset="-120"/>
               </a:rPr>
               <a:t>Palm Pals</a:t>
             </a:r>
@@ -6527,9 +6527,9 @@
                 <a:solidFill>
                   <a:srgbClr val="6B7280"/>
                 </a:solidFill>
-                <a:latin typeface="Malgun Gothic" pitchFamily="34" charset="0"/>
-                <a:ea typeface="Malgun Gothic" pitchFamily="34" charset="-122"/>
-                <a:cs typeface="Malgun Gothic" pitchFamily="34" charset="-120"/>
+                <a:latin typeface="Pretendard" pitchFamily="34" charset="0"/>
+                <a:ea typeface="Pretendard" pitchFamily="34" charset="-122"/>
+                <a:cs typeface="Pretendard" pitchFamily="34" charset="-120"/>
               </a:rPr>
               <a:t>   미니 · 백참</a:t>
             </a:r>
@@ -6566,9 +6566,9 @@
                 <a:solidFill>
                   <a:srgbClr val="1F2937"/>
                 </a:solidFill>
-                <a:latin typeface="Malgun Gothic" pitchFamily="34" charset="0"/>
-                <a:ea typeface="Malgun Gothic" pitchFamily="34" charset="-122"/>
-                <a:cs typeface="Malgun Gothic" pitchFamily="34" charset="-120"/>
+                <a:latin typeface="Pretendard" pitchFamily="34" charset="0"/>
+                <a:ea typeface="Pretendard" pitchFamily="34" charset="-122"/>
+                <a:cs typeface="Pretendard" pitchFamily="34" charset="-120"/>
               </a:rPr>
               <a:t>Miyoni</a:t>
             </a:r>
@@ -6580,9 +6580,9 @@
                 <a:solidFill>
                   <a:srgbClr val="6B7280"/>
                 </a:solidFill>
-                <a:latin typeface="Malgun Gothic" pitchFamily="34" charset="0"/>
-                <a:ea typeface="Malgun Gothic" pitchFamily="34" charset="-122"/>
-                <a:cs typeface="Malgun Gothic" pitchFamily="34" charset="-120"/>
+                <a:latin typeface="Pretendard" pitchFamily="34" charset="0"/>
+                <a:ea typeface="Pretendard" pitchFamily="34" charset="-122"/>
+                <a:cs typeface="Pretendard" pitchFamily="34" charset="-120"/>
               </a:rPr>
               <a:t>   리얼리즘 동물</a:t>
             </a:r>
@@ -6619,9 +6619,9 @@
                 <a:solidFill>
                   <a:srgbClr val="1F2937"/>
                 </a:solidFill>
-                <a:latin typeface="Malgun Gothic" pitchFamily="34" charset="0"/>
-                <a:ea typeface="Malgun Gothic" pitchFamily="34" charset="-122"/>
-                <a:cs typeface="Malgun Gothic" pitchFamily="34" charset="-120"/>
+                <a:latin typeface="Pretendard" pitchFamily="34" charset="0"/>
+                <a:ea typeface="Pretendard" pitchFamily="34" charset="-122"/>
+                <a:cs typeface="Pretendard" pitchFamily="34" charset="-120"/>
               </a:rPr>
               <a:t>Eco Nation</a:t>
             </a:r>
@@ -6633,9 +6633,9 @@
                 <a:solidFill>
                   <a:srgbClr val="6B7280"/>
                 </a:solidFill>
-                <a:latin typeface="Malgun Gothic" pitchFamily="34" charset="0"/>
-                <a:ea typeface="Malgun Gothic" pitchFamily="34" charset="-122"/>
-                <a:cs typeface="Malgun Gothic" pitchFamily="34" charset="-120"/>
+                <a:latin typeface="Pretendard" pitchFamily="34" charset="0"/>
+                <a:ea typeface="Pretendard" pitchFamily="34" charset="-122"/>
+                <a:cs typeface="Pretendard" pitchFamily="34" charset="-120"/>
               </a:rPr>
               <a:t>   친환경 · 재생소재</a:t>
             </a:r>
@@ -6672,9 +6672,9 @@
                 <a:solidFill>
                   <a:srgbClr val="1F2937"/>
                 </a:solidFill>
-                <a:latin typeface="Malgun Gothic" pitchFamily="34" charset="0"/>
-                <a:ea typeface="Malgun Gothic" pitchFamily="34" charset="-122"/>
-                <a:cs typeface="Malgun Gothic" pitchFamily="34" charset="-120"/>
+                <a:latin typeface="Pretendard" pitchFamily="34" charset="0"/>
+                <a:ea typeface="Pretendard" pitchFamily="34" charset="-122"/>
+                <a:cs typeface="Pretendard" pitchFamily="34" charset="-120"/>
               </a:rPr>
               <a:t>ebba</a:t>
             </a:r>
@@ -6686,9 +6686,9 @@
                 <a:solidFill>
                   <a:srgbClr val="6B7280"/>
                 </a:solidFill>
-                <a:latin typeface="Malgun Gothic" pitchFamily="34" charset="0"/>
-                <a:ea typeface="Malgun Gothic" pitchFamily="34" charset="-122"/>
-                <a:cs typeface="Malgun Gothic" pitchFamily="34" charset="-120"/>
+                <a:latin typeface="Pretendard" pitchFamily="34" charset="0"/>
+                <a:ea typeface="Pretendard" pitchFamily="34" charset="-122"/>
+                <a:cs typeface="Pretendard" pitchFamily="34" charset="-120"/>
               </a:rPr>
               <a:t>   베이비 센서리</a:t>
             </a:r>
@@ -6725,9 +6725,9 @@
                 <a:solidFill>
                   <a:srgbClr val="1F2937"/>
                 </a:solidFill>
-                <a:latin typeface="Malgun Gothic" pitchFamily="34" charset="0"/>
-                <a:ea typeface="Malgun Gothic" pitchFamily="34" charset="-122"/>
-                <a:cs typeface="Malgun Gothic" pitchFamily="34" charset="-120"/>
+                <a:latin typeface="Pretendard" pitchFamily="34" charset="0"/>
+                <a:ea typeface="Pretendard" pitchFamily="34" charset="-122"/>
+                <a:cs typeface="Pretendard" pitchFamily="34" charset="-120"/>
               </a:rPr>
               <a:t>Flopsie</a:t>
             </a:r>
@@ -6739,9 +6739,9 @@
                 <a:solidFill>
                   <a:srgbClr val="6B7280"/>
                 </a:solidFill>
-                <a:latin typeface="Malgun Gothic" pitchFamily="34" charset="0"/>
-                <a:ea typeface="Malgun Gothic" pitchFamily="34" charset="-122"/>
-                <a:cs typeface="Malgun Gothic" pitchFamily="34" charset="-120"/>
+                <a:latin typeface="Pretendard" pitchFamily="34" charset="0"/>
+                <a:ea typeface="Pretendard" pitchFamily="34" charset="-122"/>
+                <a:cs typeface="Pretendard" pitchFamily="34" charset="-120"/>
               </a:rPr>
               <a:t>   클래식 봉제</a:t>
             </a:r>
@@ -6805,9 +6805,9 @@
                 <a:solidFill>
                   <a:srgbClr val="DC2626"/>
                 </a:solidFill>
-                <a:latin typeface="Malgun Gothic" pitchFamily="34" charset="0"/>
-                <a:ea typeface="Malgun Gothic" pitchFamily="34" charset="-122"/>
-                <a:cs typeface="Malgun Gothic" pitchFamily="34" charset="-120"/>
+                <a:latin typeface="NEXON Lv1 Gothic" pitchFamily="34" charset="0"/>
+                <a:ea typeface="NEXON Lv1 Gothic" pitchFamily="34" charset="-122"/>
+                <a:cs typeface="NEXON Lv1 Gothic" pitchFamily="34" charset="-120"/>
               </a:rPr>
               <a:t>벤치마크 · 경쟁 브랜드</a:t>
             </a:r>
@@ -6844,9 +6844,9 @@
                 <a:solidFill>
                   <a:srgbClr val="1F2937"/>
                 </a:solidFill>
-                <a:latin typeface="Malgun Gothic" pitchFamily="34" charset="0"/>
-                <a:ea typeface="Malgun Gothic" pitchFamily="34" charset="-122"/>
-                <a:cs typeface="Malgun Gothic" pitchFamily="34" charset="-120"/>
+                <a:latin typeface="Pretendard" pitchFamily="34" charset="0"/>
+                <a:ea typeface="Pretendard" pitchFamily="34" charset="-122"/>
+                <a:cs typeface="Pretendard" pitchFamily="34" charset="-120"/>
               </a:rPr>
               <a:t>Jellycat</a:t>
             </a:r>
@@ -6858,9 +6858,9 @@
                 <a:solidFill>
                   <a:srgbClr val="6B7280"/>
                 </a:solidFill>
-                <a:latin typeface="Malgun Gothic" pitchFamily="34" charset="0"/>
-                <a:ea typeface="Malgun Gothic" pitchFamily="34" charset="-122"/>
-                <a:cs typeface="Malgun Gothic" pitchFamily="34" charset="-120"/>
+                <a:latin typeface="Pretendard" pitchFamily="34" charset="0"/>
+                <a:ea typeface="Pretendard" pitchFamily="34" charset="-122"/>
+                <a:cs typeface="Pretendard" pitchFamily="34" charset="-120"/>
               </a:rPr>
               <a:t>   감성 · 프리미엄</a:t>
             </a:r>
@@ -6897,9 +6897,9 @@
                 <a:solidFill>
                   <a:srgbClr val="1F2937"/>
                 </a:solidFill>
-                <a:latin typeface="Malgun Gothic" pitchFamily="34" charset="0"/>
-                <a:ea typeface="Malgun Gothic" pitchFamily="34" charset="-122"/>
-                <a:cs typeface="Malgun Gothic" pitchFamily="34" charset="-120"/>
+                <a:latin typeface="Pretendard" pitchFamily="34" charset="0"/>
+                <a:ea typeface="Pretendard" pitchFamily="34" charset="-122"/>
+                <a:cs typeface="Pretendard" pitchFamily="34" charset="-120"/>
               </a:rPr>
               <a:t>Squishmallows</a:t>
             </a:r>
@@ -6911,9 +6911,9 @@
                 <a:solidFill>
                   <a:srgbClr val="6B7280"/>
                 </a:solidFill>
-                <a:latin typeface="Malgun Gothic" pitchFamily="34" charset="0"/>
-                <a:ea typeface="Malgun Gothic" pitchFamily="34" charset="-122"/>
-                <a:cs typeface="Malgun Gothic" pitchFamily="34" charset="-120"/>
+                <a:latin typeface="Pretendard" pitchFamily="34" charset="0"/>
+                <a:ea typeface="Pretendard" pitchFamily="34" charset="-122"/>
+                <a:cs typeface="Pretendard" pitchFamily="34" charset="-120"/>
               </a:rPr>
               <a:t>   수집 · 대형 IP</a:t>
             </a:r>
@@ -6950,9 +6950,9 @@
                 <a:solidFill>
                   <a:srgbClr val="1F2937"/>
                 </a:solidFill>
-                <a:latin typeface="Malgun Gothic" pitchFamily="34" charset="0"/>
-                <a:ea typeface="Malgun Gothic" pitchFamily="34" charset="-122"/>
-                <a:cs typeface="Malgun Gothic" pitchFamily="34" charset="-120"/>
+                <a:latin typeface="Pretendard" pitchFamily="34" charset="0"/>
+                <a:ea typeface="Pretendard" pitchFamily="34" charset="-122"/>
+                <a:cs typeface="Pretendard" pitchFamily="34" charset="-120"/>
               </a:rPr>
               <a:t>Douglas</a:t>
             </a:r>
@@ -6964,9 +6964,9 @@
                 <a:solidFill>
                   <a:srgbClr val="6B7280"/>
                 </a:solidFill>
-                <a:latin typeface="Malgun Gothic" pitchFamily="34" charset="0"/>
-                <a:ea typeface="Malgun Gothic" pitchFamily="34" charset="-122"/>
-                <a:cs typeface="Malgun Gothic" pitchFamily="34" charset="-120"/>
+                <a:latin typeface="Pretendard" pitchFamily="34" charset="0"/>
+                <a:ea typeface="Pretendard" pitchFamily="34" charset="-122"/>
+                <a:cs typeface="Pretendard" pitchFamily="34" charset="-120"/>
               </a:rPr>
               <a:t>   리얼리즘 동물</a:t>
             </a:r>
@@ -7003,9 +7003,9 @@
                 <a:solidFill>
                   <a:srgbClr val="1F2937"/>
                 </a:solidFill>
-                <a:latin typeface="Malgun Gothic" pitchFamily="34" charset="0"/>
-                <a:ea typeface="Malgun Gothic" pitchFamily="34" charset="-122"/>
-                <a:cs typeface="Malgun Gothic" pitchFamily="34" charset="-120"/>
+                <a:latin typeface="Pretendard" pitchFamily="34" charset="0"/>
+                <a:ea typeface="Pretendard" pitchFamily="34" charset="-122"/>
+                <a:cs typeface="Pretendard" pitchFamily="34" charset="-120"/>
               </a:rPr>
               <a:t>GUND</a:t>
             </a:r>
@@ -7017,9 +7017,9 @@
                 <a:solidFill>
                   <a:srgbClr val="6B7280"/>
                 </a:solidFill>
-                <a:latin typeface="Malgun Gothic" pitchFamily="34" charset="0"/>
-                <a:ea typeface="Malgun Gothic" pitchFamily="34" charset="-122"/>
-                <a:cs typeface="Malgun Gothic" pitchFamily="34" charset="-120"/>
+                <a:latin typeface="Pretendard" pitchFamily="34" charset="0"/>
+                <a:ea typeface="Pretendard" pitchFamily="34" charset="-122"/>
+                <a:cs typeface="Pretendard" pitchFamily="34" charset="-120"/>
               </a:rPr>
               <a:t>   클래식 · 베이비</a:t>
             </a:r>
@@ -7056,9 +7056,9 @@
                 <a:solidFill>
                   <a:srgbClr val="1F2937"/>
                 </a:solidFill>
-                <a:latin typeface="Malgun Gothic" pitchFamily="34" charset="0"/>
-                <a:ea typeface="Malgun Gothic" pitchFamily="34" charset="-122"/>
-                <a:cs typeface="Malgun Gothic" pitchFamily="34" charset="-120"/>
+                <a:latin typeface="Pretendard" pitchFamily="34" charset="0"/>
+                <a:ea typeface="Pretendard" pitchFamily="34" charset="-122"/>
+                <a:cs typeface="Pretendard" pitchFamily="34" charset="-120"/>
               </a:rPr>
               <a:t>Mary Meyer</a:t>
             </a:r>
@@ -7070,9 +7070,9 @@
                 <a:solidFill>
                   <a:srgbClr val="6B7280"/>
                 </a:solidFill>
-                <a:latin typeface="Malgun Gothic" pitchFamily="34" charset="0"/>
-                <a:ea typeface="Malgun Gothic" pitchFamily="34" charset="-122"/>
-                <a:cs typeface="Malgun Gothic" pitchFamily="34" charset="-120"/>
+                <a:latin typeface="Pretendard" pitchFamily="34" charset="0"/>
+                <a:ea typeface="Pretendard" pitchFamily="34" charset="-122"/>
+                <a:cs typeface="Pretendard" pitchFamily="34" charset="-120"/>
               </a:rPr>
               <a:t>   베이비 센서리</a:t>
             </a:r>
@@ -7109,9 +7109,9 @@
                 <a:solidFill>
                   <a:srgbClr val="1F2937"/>
                 </a:solidFill>
-                <a:latin typeface="Malgun Gothic" pitchFamily="34" charset="0"/>
-                <a:ea typeface="Malgun Gothic" pitchFamily="34" charset="-122"/>
-                <a:cs typeface="Malgun Gothic" pitchFamily="34" charset="-120"/>
+                <a:latin typeface="Pretendard" pitchFamily="34" charset="0"/>
+                <a:ea typeface="Pretendard" pitchFamily="34" charset="-122"/>
+                <a:cs typeface="Pretendard" pitchFamily="34" charset="-120"/>
               </a:rPr>
               <a:t>POP MART</a:t>
             </a:r>
@@ -7123,9 +7123,9 @@
                 <a:solidFill>
                   <a:srgbClr val="6B7280"/>
                 </a:solidFill>
-                <a:latin typeface="Malgun Gothic" pitchFamily="34" charset="0"/>
-                <a:ea typeface="Malgun Gothic" pitchFamily="34" charset="-122"/>
-                <a:cs typeface="Malgun Gothic" pitchFamily="34" charset="-120"/>
+                <a:latin typeface="Pretendard" pitchFamily="34" charset="0"/>
+                <a:ea typeface="Pretendard" pitchFamily="34" charset="-122"/>
+                <a:cs typeface="Pretendard" pitchFamily="34" charset="-120"/>
               </a:rPr>
               <a:t>   블라인드박스</a:t>
             </a:r>
@@ -7165,9 +7165,9 @@
                 <a:solidFill>
                   <a:srgbClr val="6B7280"/>
                 </a:solidFill>
-                <a:latin typeface="Malgun Gothic" pitchFamily="34" charset="0"/>
-                <a:ea typeface="Malgun Gothic" pitchFamily="34" charset="-122"/>
-                <a:cs typeface="Malgun Gothic" pitchFamily="34" charset="-120"/>
+                <a:latin typeface="Pretendard" pitchFamily="34" charset="0"/>
+                <a:ea typeface="Pretendard" pitchFamily="34" charset="-122"/>
+                <a:cs typeface="Pretendard" pitchFamily="34" charset="-120"/>
               </a:rPr>
               <a:t>※ 정정 : Mary Meyer · Douglas · GUND는 오로라 브랜드가 아닌 경쟁사입니다. 기존 자료의 혼용 분류를 위와 같이 분리했습니다.</a:t>
             </a:r>
@@ -7204,9 +7204,9 @@
                 <a:solidFill>
                   <a:srgbClr val="6B7280"/>
                 </a:solidFill>
-                <a:latin typeface="Malgun Gothic" pitchFamily="34" charset="0"/>
-                <a:ea typeface="Malgun Gothic" pitchFamily="34" charset="-122"/>
-                <a:cs typeface="Malgun Gothic" pitchFamily="34" charset="-120"/>
+                <a:latin typeface="Pretendard" pitchFamily="34" charset="0"/>
+                <a:ea typeface="Pretendard" pitchFamily="34" charset="-122"/>
+                <a:cs typeface="Pretendard" pitchFamily="34" charset="-120"/>
               </a:rPr>
               <a:t>2026. 08. 11. 기준   |   6</a:t>
             </a:r>
@@ -7275,9 +7275,9 @@
                 <a:solidFill>
                   <a:srgbClr val="1E3A8A"/>
                 </a:solidFill>
-                <a:latin typeface="Malgun Gothic" pitchFamily="34" charset="0"/>
-                <a:ea typeface="Malgun Gothic" pitchFamily="34" charset="-122"/>
-                <a:cs typeface="Malgun Gothic" pitchFamily="34" charset="-120"/>
+                <a:latin typeface="Pretendard" pitchFamily="34" charset="0"/>
+                <a:ea typeface="Pretendard" pitchFamily="34" charset="-122"/>
+                <a:cs typeface="Pretendard" pitchFamily="34" charset="-120"/>
               </a:rPr>
               <a:t>MARKET SIZE</a:t>
             </a:r>
@@ -7314,9 +7314,9 @@
                 <a:solidFill>
                   <a:srgbClr val="DC2626"/>
                 </a:solidFill>
-                <a:latin typeface="Malgun Gothic" pitchFamily="34" charset="0"/>
-                <a:ea typeface="Malgun Gothic" pitchFamily="34" charset="-122"/>
-                <a:cs typeface="Malgun Gothic" pitchFamily="34" charset="-120"/>
+                <a:latin typeface="NEXON Lv1 Gothic" pitchFamily="34" charset="0"/>
+                <a:ea typeface="NEXON Lv1 Gothic" pitchFamily="34" charset="-122"/>
+                <a:cs typeface="NEXON Lv1 Gothic" pitchFamily="34" charset="-120"/>
               </a:rPr>
               <a:t>시장은 성인 컬렉터로 커진다</a:t>
             </a:r>
@@ -7396,9 +7396,9 @@
                 <a:solidFill>
                   <a:srgbClr val="1F2937"/>
                 </a:solidFill>
-                <a:latin typeface="Malgun Gothic" pitchFamily="34" charset="0"/>
-                <a:ea typeface="Malgun Gothic" pitchFamily="34" charset="-122"/>
-                <a:cs typeface="Malgun Gothic" pitchFamily="34" charset="-120"/>
+                <a:latin typeface="Pretendard" pitchFamily="34" charset="0"/>
+                <a:ea typeface="Pretendard" pitchFamily="34" charset="-122"/>
+                <a:cs typeface="Pretendard" pitchFamily="34" charset="-120"/>
               </a:rPr>
               <a:t>성인 컬렉터가 성장 동력</a:t>
             </a:r>
@@ -7462,9 +7462,9 @@
                 <a:solidFill>
                   <a:srgbClr val="1F2937"/>
                 </a:solidFill>
-                <a:latin typeface="Malgun Gothic" pitchFamily="34" charset="0"/>
-                <a:ea typeface="Malgun Gothic" pitchFamily="34" charset="-122"/>
-                <a:cs typeface="Malgun Gothic" pitchFamily="34" charset="-120"/>
+                <a:latin typeface="Pretendard" pitchFamily="34" charset="0"/>
+                <a:ea typeface="Pretendard" pitchFamily="34" charset="-122"/>
+                <a:cs typeface="Pretendard" pitchFamily="34" charset="-120"/>
               </a:rPr>
               <a:t>완구 → 자기표현 아이템</a:t>
             </a:r>
@@ -7528,9 +7528,9 @@
                 <a:solidFill>
                   <a:srgbClr val="1F2937"/>
                 </a:solidFill>
-                <a:latin typeface="Malgun Gothic" pitchFamily="34" charset="0"/>
-                <a:ea typeface="Malgun Gothic" pitchFamily="34" charset="-122"/>
-                <a:cs typeface="Malgun Gothic" pitchFamily="34" charset="-120"/>
+                <a:latin typeface="Pretendard" pitchFamily="34" charset="0"/>
+                <a:ea typeface="Pretendard" pitchFamily="34" charset="-122"/>
+                <a:cs typeface="Pretendard" pitchFamily="34" charset="-120"/>
               </a:rPr>
               <a:t>수집 · 착용 · 공유형이 유리</a:t>
             </a:r>
@@ -7594,9 +7594,9 @@
                 <a:solidFill>
                   <a:srgbClr val="DC2626"/>
                 </a:solidFill>
-                <a:latin typeface="Malgun Gothic" pitchFamily="34" charset="0"/>
-                <a:ea typeface="Malgun Gothic" pitchFamily="34" charset="-122"/>
-                <a:cs typeface="Malgun Gothic" pitchFamily="34" charset="-120"/>
+                <a:latin typeface="Pretendard" pitchFamily="34" charset="0"/>
+                <a:ea typeface="Pretendard" pitchFamily="34" charset="-122"/>
+                <a:cs typeface="Pretendard" pitchFamily="34" charset="-120"/>
               </a:rPr>
               <a:t>CAGR 약 8.3%</a:t>
             </a:r>
@@ -7636,9 +7636,9 @@
                 <a:solidFill>
                   <a:srgbClr val="6B7280"/>
                 </a:solidFill>
-                <a:latin typeface="Malgun Gothic" pitchFamily="34" charset="0"/>
-                <a:ea typeface="Malgun Gothic" pitchFamily="34" charset="-122"/>
-                <a:cs typeface="Malgun Gothic" pitchFamily="34" charset="-120"/>
+                <a:latin typeface="Pretendard" pitchFamily="34" charset="0"/>
+                <a:ea typeface="Pretendard" pitchFamily="34" charset="-122"/>
+                <a:cs typeface="Pretendard" pitchFamily="34" charset="-120"/>
               </a:rPr>
               <a:t>출처 : Grand View Research, Stuffed Animals &amp; Plush Toys Market (2025 → 2033 전망) · 2029년은 보간 추정치</a:t>
             </a:r>
@@ -7675,9 +7675,9 @@
                 <a:solidFill>
                   <a:srgbClr val="6B7280"/>
                 </a:solidFill>
-                <a:latin typeface="Malgun Gothic" pitchFamily="34" charset="0"/>
-                <a:ea typeface="Malgun Gothic" pitchFamily="34" charset="-122"/>
-                <a:cs typeface="Malgun Gothic" pitchFamily="34" charset="-120"/>
+                <a:latin typeface="Pretendard" pitchFamily="34" charset="0"/>
+                <a:ea typeface="Pretendard" pitchFamily="34" charset="-122"/>
+                <a:cs typeface="Pretendard" pitchFamily="34" charset="-120"/>
               </a:rPr>
               <a:t>2026. 08. 11. 기준   |   7</a:t>
             </a:r>
@@ -7746,9 +7746,9 @@
                 <a:solidFill>
                   <a:srgbClr val="1E3A8A"/>
                 </a:solidFill>
-                <a:latin typeface="Malgun Gothic" pitchFamily="34" charset="0"/>
-                <a:ea typeface="Malgun Gothic" pitchFamily="34" charset="-122"/>
-                <a:cs typeface="Malgun Gothic" pitchFamily="34" charset="-120"/>
+                <a:latin typeface="Pretendard" pitchFamily="34" charset="0"/>
+                <a:ea typeface="Pretendard" pitchFamily="34" charset="-122"/>
+                <a:cs typeface="Pretendard" pitchFamily="34" charset="-120"/>
               </a:rPr>
               <a:t>ACTION PRIORITY</a:t>
             </a:r>
@@ -7785,9 +7785,9 @@
                 <a:solidFill>
                   <a:srgbClr val="DC2626"/>
                 </a:solidFill>
-                <a:latin typeface="Malgun Gothic" pitchFamily="34" charset="0"/>
-                <a:ea typeface="Malgun Gothic" pitchFamily="34" charset="-122"/>
-                <a:cs typeface="Malgun Gothic" pitchFamily="34" charset="-120"/>
+                <a:latin typeface="NEXON Lv1 Gothic" pitchFamily="34" charset="0"/>
+                <a:ea typeface="NEXON Lv1 Gothic" pitchFamily="34" charset="-122"/>
+                <a:cs typeface="NEXON Lv1 Gothic" pitchFamily="34" charset="-120"/>
               </a:rPr>
               <a:t>오로라 개발 우선순위</a:t>
             </a:r>
@@ -7849,9 +7849,9 @@
                 <a:solidFill>
                   <a:srgbClr val="FFFFFF"/>
                 </a:solidFill>
-                <a:latin typeface="Malgun Gothic" pitchFamily="34" charset="0"/>
-                <a:ea typeface="Malgun Gothic" pitchFamily="34" charset="-122"/>
-                <a:cs typeface="Malgun Gothic" pitchFamily="34" charset="-120"/>
+                <a:latin typeface="Pretendard" pitchFamily="34" charset="0"/>
+                <a:ea typeface="Pretendard" pitchFamily="34" charset="-122"/>
+                <a:cs typeface="Pretendard" pitchFamily="34" charset="-120"/>
               </a:rPr>
               <a:t>1</a:t>
             </a:r>
@@ -7888,9 +7888,9 @@
                 <a:solidFill>
                   <a:srgbClr val="1F2937"/>
                 </a:solidFill>
-                <a:latin typeface="Malgun Gothic" pitchFamily="34" charset="0"/>
-                <a:ea typeface="Malgun Gothic" pitchFamily="34" charset="-122"/>
-                <a:cs typeface="Malgun Gothic" pitchFamily="34" charset="-120"/>
+                <a:latin typeface="Pretendard" pitchFamily="34" charset="0"/>
+                <a:ea typeface="Pretendard" pitchFamily="34" charset="-122"/>
+                <a:cs typeface="Pretendard" pitchFamily="34" charset="-120"/>
               </a:rPr>
               <a:t>4~6인치 미니 플러시 백참 · 클립온</a:t>
             </a:r>
@@ -7927,9 +7927,9 @@
                 <a:solidFill>
                   <a:srgbClr val="DC2626"/>
                 </a:solidFill>
-                <a:latin typeface="Malgun Gothic" pitchFamily="34" charset="0"/>
-                <a:ea typeface="Malgun Gothic" pitchFamily="34" charset="-122"/>
-                <a:cs typeface="Malgun Gothic" pitchFamily="34" charset="-120"/>
+                <a:latin typeface="Pretendard" pitchFamily="34" charset="0"/>
+                <a:ea typeface="Pretendard" pitchFamily="34" charset="-122"/>
+                <a:cs typeface="Pretendard" pitchFamily="34" charset="-120"/>
               </a:rPr>
               <a:t>착용형 수집 트렌드</a:t>
             </a:r>
@@ -8014,9 +8014,9 @@
                 <a:solidFill>
                   <a:srgbClr val="FFFFFF"/>
                 </a:solidFill>
-                <a:latin typeface="Malgun Gothic" pitchFamily="34" charset="0"/>
-                <a:ea typeface="Malgun Gothic" pitchFamily="34" charset="-122"/>
-                <a:cs typeface="Malgun Gothic" pitchFamily="34" charset="-120"/>
+                <a:latin typeface="Pretendard" pitchFamily="34" charset="0"/>
+                <a:ea typeface="Pretendard" pitchFamily="34" charset="-122"/>
+                <a:cs typeface="Pretendard" pitchFamily="34" charset="-120"/>
               </a:rPr>
               <a:t>2</a:t>
             </a:r>
@@ -8053,9 +8053,9 @@
                 <a:solidFill>
                   <a:srgbClr val="1F2937"/>
                 </a:solidFill>
-                <a:latin typeface="Malgun Gothic" pitchFamily="34" charset="0"/>
-                <a:ea typeface="Malgun Gothic" pitchFamily="34" charset="-122"/>
-                <a:cs typeface="Malgun Gothic" pitchFamily="34" charset="-120"/>
+                <a:latin typeface="Pretendard" pitchFamily="34" charset="0"/>
+                <a:ea typeface="Pretendard" pitchFamily="34" charset="-122"/>
+                <a:cs typeface="Pretendard" pitchFamily="34" charset="-120"/>
               </a:rPr>
               <a:t>블라인드박스형 캐릭터 봉제 시리즈</a:t>
             </a:r>
@@ -8092,9 +8092,9 @@
                 <a:solidFill>
                   <a:srgbClr val="DC2626"/>
                 </a:solidFill>
-                <a:latin typeface="Malgun Gothic" pitchFamily="34" charset="0"/>
-                <a:ea typeface="Malgun Gothic" pitchFamily="34" charset="-122"/>
-                <a:cs typeface="Malgun Gothic" pitchFamily="34" charset="-120"/>
+                <a:latin typeface="Pretendard" pitchFamily="34" charset="0"/>
+                <a:ea typeface="Pretendard" pitchFamily="34" charset="-122"/>
+                <a:cs typeface="Pretendard" pitchFamily="34" charset="-120"/>
               </a:rPr>
               <a:t>언박싱 · 수집 문화</a:t>
             </a:r>
@@ -8179,9 +8179,9 @@
                 <a:solidFill>
                   <a:srgbClr val="FFFFFF"/>
                 </a:solidFill>
-                <a:latin typeface="Malgun Gothic" pitchFamily="34" charset="0"/>
-                <a:ea typeface="Malgun Gothic" pitchFamily="34" charset="-122"/>
-                <a:cs typeface="Malgun Gothic" pitchFamily="34" charset="-120"/>
+                <a:latin typeface="Pretendard" pitchFamily="34" charset="0"/>
+                <a:ea typeface="Pretendard" pitchFamily="34" charset="-122"/>
+                <a:cs typeface="Pretendard" pitchFamily="34" charset="-120"/>
               </a:rPr>
               <a:t>3</a:t>
             </a:r>
@@ -8218,9 +8218,9 @@
                 <a:solidFill>
                   <a:srgbClr val="1F2937"/>
                 </a:solidFill>
-                <a:latin typeface="Malgun Gothic" pitchFamily="34" charset="0"/>
-                <a:ea typeface="Malgun Gothic" pitchFamily="34" charset="-122"/>
-                <a:cs typeface="Malgun Gothic" pitchFamily="34" charset="-120"/>
+                <a:latin typeface="Pretendard" pitchFamily="34" charset="0"/>
+                <a:ea typeface="Pretendard" pitchFamily="34" charset="-122"/>
+                <a:cs typeface="Pretendard" pitchFamily="34" charset="-120"/>
               </a:rPr>
               <a:t>온열 · 무게감 · 향기 기능성 plush</a:t>
             </a:r>
@@ -8257,9 +8257,9 @@
                 <a:solidFill>
                   <a:srgbClr val="DC2626"/>
                 </a:solidFill>
-                <a:latin typeface="Malgun Gothic" pitchFamily="34" charset="0"/>
-                <a:ea typeface="Malgun Gothic" pitchFamily="34" charset="-122"/>
-                <a:cs typeface="Malgun Gothic" pitchFamily="34" charset="-120"/>
+                <a:latin typeface="Pretendard" pitchFamily="34" charset="0"/>
+                <a:ea typeface="Pretendard" pitchFamily="34" charset="-122"/>
+                <a:cs typeface="Pretendard" pitchFamily="34" charset="-120"/>
               </a:rPr>
               <a:t>힐링 · 수면 케어 확장</a:t>
             </a:r>
@@ -8344,9 +8344,9 @@
                 <a:solidFill>
                   <a:srgbClr val="1E3A8A"/>
                 </a:solidFill>
-                <a:latin typeface="Malgun Gothic" pitchFamily="34" charset="0"/>
-                <a:ea typeface="Malgun Gothic" pitchFamily="34" charset="-122"/>
-                <a:cs typeface="Malgun Gothic" pitchFamily="34" charset="-120"/>
+                <a:latin typeface="Pretendard" pitchFamily="34" charset="0"/>
+                <a:ea typeface="Pretendard" pitchFamily="34" charset="-122"/>
+                <a:cs typeface="Pretendard" pitchFamily="34" charset="-120"/>
               </a:rPr>
               <a:t>4</a:t>
             </a:r>
@@ -8383,9 +8383,9 @@
                 <a:solidFill>
                   <a:srgbClr val="1F2937"/>
                 </a:solidFill>
-                <a:latin typeface="Malgun Gothic" pitchFamily="34" charset="0"/>
-                <a:ea typeface="Malgun Gothic" pitchFamily="34" charset="-122"/>
-                <a:cs typeface="Malgun Gothic" pitchFamily="34" charset="-120"/>
+                <a:latin typeface="Pretendard" pitchFamily="34" charset="0"/>
+                <a:ea typeface="Pretendard" pitchFamily="34" charset="-122"/>
+                <a:cs typeface="Pretendard" pitchFamily="34" charset="-120"/>
               </a:rPr>
               <a:t>어글리 큐트 신규 캐릭터</a:t>
             </a:r>
@@ -8422,9 +8422,9 @@
                 <a:solidFill>
                   <a:srgbClr val="1E3A8A"/>
                 </a:solidFill>
-                <a:latin typeface="Malgun Gothic" pitchFamily="34" charset="0"/>
-                <a:ea typeface="Malgun Gothic" pitchFamily="34" charset="-122"/>
-                <a:cs typeface="Malgun Gothic" pitchFamily="34" charset="-120"/>
+                <a:latin typeface="Pretendard" pitchFamily="34" charset="0"/>
+                <a:ea typeface="Pretendard" pitchFamily="34" charset="-122"/>
+                <a:cs typeface="Pretendard" pitchFamily="34" charset="-120"/>
               </a:rPr>
               <a:t>키덜트 · SNS 바이럴</a:t>
             </a:r>
@@ -8509,9 +8509,9 @@
                 <a:solidFill>
                   <a:srgbClr val="1E3A8A"/>
                 </a:solidFill>
-                <a:latin typeface="Malgun Gothic" pitchFamily="34" charset="0"/>
-                <a:ea typeface="Malgun Gothic" pitchFamily="34" charset="-122"/>
-                <a:cs typeface="Malgun Gothic" pitchFamily="34" charset="-120"/>
+                <a:latin typeface="Pretendard" pitchFamily="34" charset="0"/>
+                <a:ea typeface="Pretendard" pitchFamily="34" charset="-122"/>
+                <a:cs typeface="Pretendard" pitchFamily="34" charset="-120"/>
               </a:rPr>
               <a:t>5</a:t>
             </a:r>
@@ -8548,9 +8548,9 @@
                 <a:solidFill>
                   <a:srgbClr val="1F2937"/>
                 </a:solidFill>
-                <a:latin typeface="Malgun Gothic" pitchFamily="34" charset="0"/>
-                <a:ea typeface="Malgun Gothic" pitchFamily="34" charset="-122"/>
-                <a:cs typeface="Malgun Gothic" pitchFamily="34" charset="-120"/>
+                <a:latin typeface="Pretendard" pitchFamily="34" charset="0"/>
+                <a:ea typeface="Pretendard" pitchFamily="34" charset="-122"/>
+                <a:cs typeface="Pretendard" pitchFamily="34" charset="-120"/>
               </a:rPr>
               <a:t>Miyoni · Eco Nation 프리미엄 라인</a:t>
             </a:r>
@@ -8587,9 +8587,9 @@
                 <a:solidFill>
                   <a:srgbClr val="1E3A8A"/>
                 </a:solidFill>
-                <a:latin typeface="Malgun Gothic" pitchFamily="34" charset="0"/>
-                <a:ea typeface="Malgun Gothic" pitchFamily="34" charset="-122"/>
-                <a:cs typeface="Malgun Gothic" pitchFamily="34" charset="-120"/>
+                <a:latin typeface="Pretendard" pitchFamily="34" charset="0"/>
+                <a:ea typeface="Pretendard" pitchFamily="34" charset="-122"/>
+                <a:cs typeface="Pretendard" pitchFamily="34" charset="-120"/>
               </a:rPr>
               <a:t>기존 강점 + 친환경</a:t>
             </a:r>
@@ -8674,9 +8674,9 @@
                 <a:solidFill>
                   <a:srgbClr val="1E3A8A"/>
                 </a:solidFill>
-                <a:latin typeface="Malgun Gothic" pitchFamily="34" charset="0"/>
-                <a:ea typeface="Malgun Gothic" pitchFamily="34" charset="-122"/>
-                <a:cs typeface="Malgun Gothic" pitchFamily="34" charset="-120"/>
+                <a:latin typeface="Pretendard" pitchFamily="34" charset="0"/>
+                <a:ea typeface="Pretendard" pitchFamily="34" charset="-122"/>
+                <a:cs typeface="Pretendard" pitchFamily="34" charset="-120"/>
               </a:rPr>
               <a:t>6</a:t>
             </a:r>
@@ -8713,9 +8713,9 @@
                 <a:solidFill>
                   <a:srgbClr val="1F2937"/>
                 </a:solidFill>
-                <a:latin typeface="Malgun Gothic" pitchFamily="34" charset="0"/>
-                <a:ea typeface="Malgun Gothic" pitchFamily="34" charset="-122"/>
-                <a:cs typeface="Malgun Gothic" pitchFamily="34" charset="-120"/>
+                <a:latin typeface="Pretendard" pitchFamily="34" charset="0"/>
+                <a:ea typeface="Pretendard" pitchFamily="34" charset="-122"/>
+                <a:cs typeface="Pretendard" pitchFamily="34" charset="-120"/>
               </a:rPr>
               <a:t>ebba 베이비 센서리 강화</a:t>
             </a:r>
@@ -8752,9 +8752,9 @@
                 <a:solidFill>
                   <a:srgbClr val="1E3A8A"/>
                 </a:solidFill>
-                <a:latin typeface="Malgun Gothic" pitchFamily="34" charset="0"/>
-                <a:ea typeface="Malgun Gothic" pitchFamily="34" charset="-122"/>
-                <a:cs typeface="Malgun Gothic" pitchFamily="34" charset="-120"/>
+                <a:latin typeface="Pretendard" pitchFamily="34" charset="0"/>
+                <a:ea typeface="Pretendard" pitchFamily="34" charset="-122"/>
+                <a:cs typeface="Pretendard" pitchFamily="34" charset="-120"/>
               </a:rPr>
               <a:t>출산 · 육아 선물 수요</a:t>
             </a:r>
@@ -8839,9 +8839,9 @@
                 <a:solidFill>
                   <a:srgbClr val="1E3A8A"/>
                 </a:solidFill>
-                <a:latin typeface="Malgun Gothic" pitchFamily="34" charset="0"/>
-                <a:ea typeface="Malgun Gothic" pitchFamily="34" charset="-122"/>
-                <a:cs typeface="Malgun Gothic" pitchFamily="34" charset="-120"/>
+                <a:latin typeface="Pretendard" pitchFamily="34" charset="0"/>
+                <a:ea typeface="Pretendard" pitchFamily="34" charset="-122"/>
+                <a:cs typeface="Pretendard" pitchFamily="34" charset="-120"/>
               </a:rPr>
               <a:t>7</a:t>
             </a:r>
@@ -8878,9 +8878,9 @@
                 <a:solidFill>
                   <a:srgbClr val="1F2937"/>
                 </a:solidFill>
-                <a:latin typeface="Malgun Gothic" pitchFamily="34" charset="0"/>
-                <a:ea typeface="Malgun Gothic" pitchFamily="34" charset="-122"/>
-                <a:cs typeface="Malgun Gothic" pitchFamily="34" charset="-120"/>
+                <a:latin typeface="Pretendard" pitchFamily="34" charset="0"/>
+                <a:ea typeface="Pretendard" pitchFamily="34" charset="-122"/>
+                <a:cs typeface="Pretendard" pitchFamily="34" charset="-120"/>
               </a:rPr>
               <a:t>푸드 · 디저트 · 홈데코 plush</a:t>
             </a:r>
@@ -8917,9 +8917,9 @@
                 <a:solidFill>
                   <a:srgbClr val="1E3A8A"/>
                 </a:solidFill>
-                <a:latin typeface="Malgun Gothic" pitchFamily="34" charset="0"/>
-                <a:ea typeface="Malgun Gothic" pitchFamily="34" charset="-122"/>
-                <a:cs typeface="Malgun Gothic" pitchFamily="34" charset="-120"/>
+                <a:latin typeface="Pretendard" pitchFamily="34" charset="0"/>
+                <a:ea typeface="Pretendard" pitchFamily="34" charset="-122"/>
+                <a:cs typeface="Pretendard" pitchFamily="34" charset="-120"/>
               </a:rPr>
               <a:t>라이프스타일 채널</a:t>
             </a:r>
@@ -9004,9 +9004,9 @@
                 <a:solidFill>
                   <a:srgbClr val="1E3A8A"/>
                 </a:solidFill>
-                <a:latin typeface="Malgun Gothic" pitchFamily="34" charset="0"/>
-                <a:ea typeface="Malgun Gothic" pitchFamily="34" charset="-122"/>
-                <a:cs typeface="Malgun Gothic" pitchFamily="34" charset="-120"/>
+                <a:latin typeface="Pretendard" pitchFamily="34" charset="0"/>
+                <a:ea typeface="Pretendard" pitchFamily="34" charset="-122"/>
+                <a:cs typeface="Pretendard" pitchFamily="34" charset="-120"/>
               </a:rPr>
               <a:t>8</a:t>
             </a:r>
@@ -9043,9 +9043,9 @@
                 <a:solidFill>
                   <a:srgbClr val="1F2937"/>
                 </a:solidFill>
-                <a:latin typeface="Malgun Gothic" pitchFamily="34" charset="0"/>
-                <a:ea typeface="Malgun Gothic" pitchFamily="34" charset="-122"/>
-                <a:cs typeface="Malgun Gothic" pitchFamily="34" charset="-120"/>
+                <a:latin typeface="Pretendard" pitchFamily="34" charset="0"/>
+                <a:ea typeface="Pretendard" pitchFamily="34" charset="-122"/>
+                <a:cs typeface="Pretendard" pitchFamily="34" charset="-120"/>
               </a:rPr>
               <a:t>외부 IP 미니 plush 협업</a:t>
             </a:r>
@@ -9082,9 +9082,9 @@
                 <a:solidFill>
                   <a:srgbClr val="1E3A8A"/>
                 </a:solidFill>
-                <a:latin typeface="Malgun Gothic" pitchFamily="34" charset="0"/>
-                <a:ea typeface="Malgun Gothic" pitchFamily="34" charset="-122"/>
-                <a:cs typeface="Malgun Gothic" pitchFamily="34" charset="-120"/>
+                <a:latin typeface="Pretendard" pitchFamily="34" charset="0"/>
+                <a:ea typeface="Pretendard" pitchFamily="34" charset="-122"/>
+                <a:cs typeface="Pretendard" pitchFamily="34" charset="-120"/>
               </a:rPr>
               <a:t>선물 · 위시리스트 수요</a:t>
             </a:r>
@@ -9124,9 +9124,9 @@
                 <a:solidFill>
                   <a:srgbClr val="6B7280"/>
                 </a:solidFill>
-                <a:latin typeface="Malgun Gothic" pitchFamily="34" charset="0"/>
-                <a:ea typeface="Malgun Gothic" pitchFamily="34" charset="-122"/>
-                <a:cs typeface="Malgun Gothic" pitchFamily="34" charset="-120"/>
+                <a:latin typeface="Pretendard" pitchFamily="34" charset="0"/>
+                <a:ea typeface="Pretendard" pitchFamily="34" charset="-122"/>
+                <a:cs typeface="Pretendard" pitchFamily="34" charset="-120"/>
               </a:rPr>
               <a:t>1~3순위 : 2026 하반기 선행 개발 착수   |   4~8순위 : 2027 라인업 검토</a:t>
             </a:r>
@@ -9163,9 +9163,9 @@
                 <a:solidFill>
                   <a:srgbClr val="6B7280"/>
                 </a:solidFill>
-                <a:latin typeface="Malgun Gothic" pitchFamily="34" charset="0"/>
-                <a:ea typeface="Malgun Gothic" pitchFamily="34" charset="-122"/>
-                <a:cs typeface="Malgun Gothic" pitchFamily="34" charset="-120"/>
+                <a:latin typeface="Pretendard" pitchFamily="34" charset="0"/>
+                <a:ea typeface="Pretendard" pitchFamily="34" charset="-122"/>
+                <a:cs typeface="Pretendard" pitchFamily="34" charset="-120"/>
               </a:rPr>
               <a:t>2026. 08. 11. 기준   |   8</a:t>
             </a:r>
@@ -9234,9 +9234,9 @@
                 <a:solidFill>
                   <a:srgbClr val="1E3A8A"/>
                 </a:solidFill>
-                <a:latin typeface="Malgun Gothic" pitchFamily="34" charset="0"/>
-                <a:ea typeface="Malgun Gothic" pitchFamily="34" charset="-122"/>
-                <a:cs typeface="Malgun Gothic" pitchFamily="34" charset="-120"/>
+                <a:latin typeface="Pretendard" pitchFamily="34" charset="0"/>
+                <a:ea typeface="Pretendard" pitchFamily="34" charset="-122"/>
+                <a:cs typeface="Pretendard" pitchFamily="34" charset="-120"/>
               </a:rPr>
               <a:t>CONCLUSION</a:t>
             </a:r>
@@ -9273,9 +9273,9 @@
                 <a:solidFill>
                   <a:srgbClr val="DC2626"/>
                 </a:solidFill>
-                <a:latin typeface="Malgun Gothic" pitchFamily="34" charset="0"/>
-                <a:ea typeface="Malgun Gothic" pitchFamily="34" charset="-122"/>
-                <a:cs typeface="Malgun Gothic" pitchFamily="34" charset="-120"/>
+                <a:latin typeface="NEXON Lv1 Gothic" pitchFamily="34" charset="0"/>
+                <a:ea typeface="NEXON Lv1 Gothic" pitchFamily="34" charset="-122"/>
+                <a:cs typeface="NEXON Lv1 Gothic" pitchFamily="34" charset="-120"/>
               </a:rPr>
               <a:t>결론 및 다음 단계</a:t>
             </a:r>
@@ -9342,9 +9342,9 @@
                 <a:solidFill>
                   <a:srgbClr val="DC2626"/>
                 </a:solidFill>
-                <a:latin typeface="Malgun Gothic" pitchFamily="34" charset="0"/>
-                <a:ea typeface="Malgun Gothic" pitchFamily="34" charset="-122"/>
-                <a:cs typeface="Malgun Gothic" pitchFamily="34" charset="-120"/>
+                <a:latin typeface="NEXON Lv1 Gothic" pitchFamily="34" charset="0"/>
+                <a:ea typeface="NEXON Lv1 Gothic" pitchFamily="34" charset="-122"/>
+                <a:cs typeface="NEXON Lv1 Gothic" pitchFamily="34" charset="-120"/>
               </a:rPr>
               <a:t>네 지표를 교차하면, 지금 잘 팔리는 봉제완구가 아니라</a:t>
             </a:r>
@@ -9362,9 +9362,9 @@
                 <a:solidFill>
                   <a:srgbClr val="DC2626"/>
                 </a:solidFill>
-                <a:latin typeface="Malgun Gothic" pitchFamily="34" charset="0"/>
-                <a:ea typeface="Malgun Gothic" pitchFamily="34" charset="-122"/>
-                <a:cs typeface="Malgun Gothic" pitchFamily="34" charset="-120"/>
+                <a:latin typeface="NEXON Lv1 Gothic" pitchFamily="34" charset="0"/>
+                <a:ea typeface="NEXON Lv1 Gothic" pitchFamily="34" charset="-122"/>
+                <a:cs typeface="NEXON Lv1 Gothic" pitchFamily="34" charset="-120"/>
               </a:rPr>
               <a:t>앞으로 성장할 상품군이 보인다.</a:t>
             </a:r>
@@ -9428,9 +9428,9 @@
                 <a:solidFill>
                   <a:srgbClr val="DC2626"/>
                 </a:solidFill>
-                <a:latin typeface="Malgun Gothic" pitchFamily="34" charset="0"/>
-                <a:ea typeface="Malgun Gothic" pitchFamily="34" charset="-122"/>
-                <a:cs typeface="Malgun Gothic" pitchFamily="34" charset="-120"/>
+                <a:latin typeface="Pretendard" pitchFamily="34" charset="0"/>
+                <a:ea typeface="Pretendard" pitchFamily="34" charset="-122"/>
+                <a:cs typeface="Pretendard" pitchFamily="34" charset="-120"/>
               </a:rPr>
               <a:t>01</a:t>
             </a:r>
@@ -9470,9 +9470,9 @@
                 <a:solidFill>
                   <a:srgbClr val="1F2937"/>
                 </a:solidFill>
-                <a:latin typeface="Malgun Gothic" pitchFamily="34" charset="0"/>
-                <a:ea typeface="Malgun Gothic" pitchFamily="34" charset="-122"/>
-                <a:cs typeface="Malgun Gothic" pitchFamily="34" charset="-120"/>
+                <a:latin typeface="Pretendard" pitchFamily="34" charset="0"/>
+                <a:ea typeface="Pretendard" pitchFamily="34" charset="-122"/>
+                <a:cs typeface="Pretendard" pitchFamily="34" charset="-120"/>
               </a:rPr>
               <a:t>랭킹 주 1회</a:t>
             </a:r>
@@ -9490,9 +9490,9 @@
                 <a:solidFill>
                   <a:srgbClr val="1F2937"/>
                 </a:solidFill>
-                <a:latin typeface="Malgun Gothic" pitchFamily="34" charset="0"/>
-                <a:ea typeface="Malgun Gothic" pitchFamily="34" charset="-122"/>
-                <a:cs typeface="Malgun Gothic" pitchFamily="34" charset="-120"/>
+                <a:latin typeface="Pretendard" pitchFamily="34" charset="0"/>
+                <a:ea typeface="Pretendard" pitchFamily="34" charset="-122"/>
+                <a:cs typeface="Pretendard" pitchFamily="34" charset="-120"/>
               </a:rPr>
               <a:t>캡처 · 아카이브</a:t>
             </a:r>
@@ -9529,9 +9529,9 @@
                 <a:solidFill>
                   <a:srgbClr val="6B7280"/>
                 </a:solidFill>
-                <a:latin typeface="Malgun Gothic" pitchFamily="34" charset="0"/>
-                <a:ea typeface="Malgun Gothic" pitchFamily="34" charset="-122"/>
-                <a:cs typeface="Malgun Gothic" pitchFamily="34" charset="-120"/>
+                <a:latin typeface="Pretendard" pitchFamily="34" charset="0"/>
+                <a:ea typeface="Pretendard" pitchFamily="34" charset="-122"/>
+                <a:cs typeface="Pretendard" pitchFamily="34" charset="-120"/>
               </a:rPr>
               <a:t>캡처 일시 병기 필수</a:t>
             </a:r>
@@ -9595,9 +9595,9 @@
                 <a:solidFill>
                   <a:srgbClr val="1E3A8A"/>
                 </a:solidFill>
-                <a:latin typeface="Malgun Gothic" pitchFamily="34" charset="0"/>
-                <a:ea typeface="Malgun Gothic" pitchFamily="34" charset="-122"/>
-                <a:cs typeface="Malgun Gothic" pitchFamily="34" charset="-120"/>
+                <a:latin typeface="Pretendard" pitchFamily="34" charset="0"/>
+                <a:ea typeface="Pretendard" pitchFamily="34" charset="-122"/>
+                <a:cs typeface="Pretendard" pitchFamily="34" charset="-120"/>
               </a:rPr>
               <a:t>02</a:t>
             </a:r>
@@ -9637,9 +9637,9 @@
                 <a:solidFill>
                   <a:srgbClr val="1F2937"/>
                 </a:solidFill>
-                <a:latin typeface="Malgun Gothic" pitchFamily="34" charset="0"/>
-                <a:ea typeface="Malgun Gothic" pitchFamily="34" charset="-122"/>
-                <a:cs typeface="Malgun Gothic" pitchFamily="34" charset="-120"/>
+                <a:latin typeface="Pretendard" pitchFamily="34" charset="0"/>
+                <a:ea typeface="Pretendard" pitchFamily="34" charset="-122"/>
+                <a:cs typeface="Pretendard" pitchFamily="34" charset="-120"/>
               </a:rPr>
               <a:t>교차 상위</a:t>
             </a:r>
@@ -9657,9 +9657,9 @@
                 <a:solidFill>
                   <a:srgbClr val="1F2937"/>
                 </a:solidFill>
-                <a:latin typeface="Malgun Gothic" pitchFamily="34" charset="0"/>
-                <a:ea typeface="Malgun Gothic" pitchFamily="34" charset="-122"/>
-                <a:cs typeface="Malgun Gothic" pitchFamily="34" charset="-120"/>
+                <a:latin typeface="Pretendard" pitchFamily="34" charset="0"/>
+                <a:ea typeface="Pretendard" pitchFamily="34" charset="-122"/>
+                <a:cs typeface="Pretendard" pitchFamily="34" charset="-120"/>
               </a:rPr>
               <a:t>SKU 리스트업</a:t>
             </a:r>
@@ -9696,9 +9696,9 @@
                 <a:solidFill>
                   <a:srgbClr val="6B7280"/>
                 </a:solidFill>
-                <a:latin typeface="Malgun Gothic" pitchFamily="34" charset="0"/>
-                <a:ea typeface="Malgun Gothic" pitchFamily="34" charset="-122"/>
-                <a:cs typeface="Malgun Gothic" pitchFamily="34" charset="-120"/>
+                <a:latin typeface="Pretendard" pitchFamily="34" charset="0"/>
+                <a:ea typeface="Pretendard" pitchFamily="34" charset="-122"/>
+                <a:cs typeface="Pretendard" pitchFamily="34" charset="-120"/>
               </a:rPr>
               <a:t>경쟁사 · 소재 · 가격대 분석</a:t>
             </a:r>
@@ -9762,9 +9762,9 @@
                 <a:solidFill>
                   <a:srgbClr val="1E3A8A"/>
                 </a:solidFill>
-                <a:latin typeface="Malgun Gothic" pitchFamily="34" charset="0"/>
-                <a:ea typeface="Malgun Gothic" pitchFamily="34" charset="-122"/>
-                <a:cs typeface="Malgun Gothic" pitchFamily="34" charset="-120"/>
+                <a:latin typeface="Pretendard" pitchFamily="34" charset="0"/>
+                <a:ea typeface="Pretendard" pitchFamily="34" charset="-122"/>
+                <a:cs typeface="Pretendard" pitchFamily="34" charset="-120"/>
               </a:rPr>
               <a:t>03</a:t>
             </a:r>
@@ -9804,9 +9804,9 @@
                 <a:solidFill>
                   <a:srgbClr val="1F2937"/>
                 </a:solidFill>
-                <a:latin typeface="Malgun Gothic" pitchFamily="34" charset="0"/>
-                <a:ea typeface="Malgun Gothic" pitchFamily="34" charset="-122"/>
-                <a:cs typeface="Malgun Gothic" pitchFamily="34" charset="-120"/>
+                <a:latin typeface="Pretendard" pitchFamily="34" charset="0"/>
+                <a:ea typeface="Pretendard" pitchFamily="34" charset="-122"/>
+                <a:cs typeface="Pretendard" pitchFamily="34" charset="-120"/>
               </a:rPr>
               <a:t>미니 · 백참 라인</a:t>
             </a:r>
@@ -9824,9 +9824,9 @@
                 <a:solidFill>
                   <a:srgbClr val="1F2937"/>
                 </a:solidFill>
-                <a:latin typeface="Malgun Gothic" pitchFamily="34" charset="0"/>
-                <a:ea typeface="Malgun Gothic" pitchFamily="34" charset="-122"/>
-                <a:cs typeface="Malgun Gothic" pitchFamily="34" charset="-120"/>
+                <a:latin typeface="Pretendard" pitchFamily="34" charset="0"/>
+                <a:ea typeface="Pretendard" pitchFamily="34" charset="-122"/>
+                <a:cs typeface="Pretendard" pitchFamily="34" charset="-120"/>
               </a:rPr>
               <a:t>선행 기획</a:t>
             </a:r>
@@ -9863,9 +9863,9 @@
                 <a:solidFill>
                   <a:srgbClr val="6B7280"/>
                 </a:solidFill>
-                <a:latin typeface="Malgun Gothic" pitchFamily="34" charset="0"/>
-                <a:ea typeface="Malgun Gothic" pitchFamily="34" charset="-122"/>
-                <a:cs typeface="Malgun Gothic" pitchFamily="34" charset="-120"/>
+                <a:latin typeface="Pretendard" pitchFamily="34" charset="0"/>
+                <a:ea typeface="Pretendard" pitchFamily="34" charset="-122"/>
+                <a:cs typeface="Pretendard" pitchFamily="34" charset="-120"/>
               </a:rPr>
               <a:t>2026 하반기 착수</a:t>
             </a:r>
@@ -9905,9 +9905,9 @@
                 <a:solidFill>
                   <a:srgbClr val="6B7280"/>
                 </a:solidFill>
-                <a:latin typeface="Malgun Gothic" pitchFamily="34" charset="0"/>
-                <a:ea typeface="Malgun Gothic" pitchFamily="34" charset="-122"/>
-                <a:cs typeface="Malgun Gothic" pitchFamily="34" charset="-120"/>
+                <a:latin typeface="Pretendard" pitchFamily="34" charset="0"/>
+                <a:ea typeface="Pretendard" pitchFamily="34" charset="-122"/>
+                <a:cs typeface="Pretendard" pitchFamily="34" charset="-120"/>
               </a:rPr>
               <a:t>※ 본 자료의 데이터 기준일은 2026. 08. 11. (금일 조회 기준)입니다. Amazon 랭킹은 접속 시점 · 지역 · 계정 · 재고에 따라 변동되므로, 재인용 시 조회 일시를 반드시 함께 기재하십시오.</a:t>
             </a:r>
@@ -9944,9 +9944,9 @@
                 <a:solidFill>
                   <a:srgbClr val="6B7280"/>
                 </a:solidFill>
-                <a:latin typeface="Malgun Gothic" pitchFamily="34" charset="0"/>
-                <a:ea typeface="Malgun Gothic" pitchFamily="34" charset="-122"/>
-                <a:cs typeface="Malgun Gothic" pitchFamily="34" charset="-120"/>
+                <a:latin typeface="Pretendard" pitchFamily="34" charset="0"/>
+                <a:ea typeface="Pretendard" pitchFamily="34" charset="-122"/>
+                <a:cs typeface="Pretendard" pitchFamily="34" charset="-120"/>
               </a:rPr>
               <a:t>2026. 08. 11. 기준   |   9</a:t>
             </a:r>

</xml_diff>